<commit_message>
feat: complete click-based rescue game
</commit_message>
<xml_diff>
--- a/docs/architecture/pixel-panic-current-architecture.pptx
+++ b/docs/architecture/pixel-panic-current-architecture.pptx
@@ -2,16 +2,16 @@
 <file path=ppt/presentation.xml><?xml version="1.0" encoding="utf-8"?>
 <p:presentation xmlns:p="http://schemas.openxmlformats.org/presentationml/2006/main">
   <p:sldMasterIdLst>
-    <p:sldMasterId xmlns:r="http://schemas.openxmlformats.org/officeDocument/2006/relationships" id="2147483648" r:id="R523c15602a8541e3"/>
+    <p:sldMasterId xmlns:r="http://schemas.openxmlformats.org/officeDocument/2006/relationships" id="2147483648" r:id="Rbcdee22caa7a485e"/>
   </p:sldMasterIdLst>
   <p:notesMasterIdLst>
-    <p:notesMasterId xmlns:r="http://schemas.openxmlformats.org/officeDocument/2006/relationships" r:id="R5cf0c29f9cc14667"/>
+    <p:notesMasterId xmlns:r="http://schemas.openxmlformats.org/officeDocument/2006/relationships" r:id="R2a1c4425ed8a4d18"/>
   </p:notesMasterIdLst>
   <p:sldIdLst>
-    <p:sldId xmlns:r="http://schemas.openxmlformats.org/officeDocument/2006/relationships" id="256" r:id="R7cd980fb18464f32"/>
-    <p:sldId xmlns:r="http://schemas.openxmlformats.org/officeDocument/2006/relationships" id="257" r:id="Rfe79f0bb361549b1"/>
-    <p:sldId xmlns:r="http://schemas.openxmlformats.org/officeDocument/2006/relationships" id="258" r:id="Rb93270b063384cdf"/>
-    <p:sldId xmlns:r="http://schemas.openxmlformats.org/officeDocument/2006/relationships" id="259" r:id="R309532fc60344361"/>
+    <p:sldId xmlns:r="http://schemas.openxmlformats.org/officeDocument/2006/relationships" id="256" r:id="R9d81712835ba474d"/>
+    <p:sldId xmlns:r="http://schemas.openxmlformats.org/officeDocument/2006/relationships" id="257" r:id="R170f037f4761477d"/>
+    <p:sldId xmlns:r="http://schemas.openxmlformats.org/officeDocument/2006/relationships" id="258" r:id="Ra2803effaad34867"/>
+    <p:sldId xmlns:r="http://schemas.openxmlformats.org/officeDocument/2006/relationships" id="259" r:id="Rd8add7553b184cbc"/>
   </p:sldIdLst>
   <p:sldSz cx="12192000" cy="6858000"/>
   <p:notesSz cx="6858000" cy="9144000"/>
@@ -425,7 +425,7 @@
           </a:p>
           <a:p xmlns:a="http://schemas.openxmlformats.org/drawingml/2006/main">
             <a:r>
-              <a:t>- Repository README.md, app/api/plan/route.ts, lib/server/oci-plan-client.ts</a:t>
+              <a:t>- Repository README.md, app/api/dialogue/route.ts, lib/server/oci-dialogue-client.ts</a:t>
             </a:r>
           </a:p>
           <a:p xmlns:a="http://schemas.openxmlformats.org/drawingml/2006/main">
@@ -658,7 +658,7 @@
   </p:cSld>
   <p:clrMap bg1="lt1" tx1="dk1" bg2="lt2" tx2="dk2" accent1="accent1" accent2="accent2" accent3="accent3" accent4="accent4" accent5="accent5" accent6="accent6" hlink="hlink" folHlink="folHlink"/>
   <p:sldLayoutIdLst>
-    <p:sldLayoutId xmlns:r="http://schemas.openxmlformats.org/officeDocument/2006/relationships" id="2147483649" r:id="R7cbc7af1f29f4d24"/>
+    <p:sldLayoutId xmlns:r="http://schemas.openxmlformats.org/officeDocument/2006/relationships" id="2147483649" r:id="Rdd968a45e7974695"/>
   </p:sldLayoutIdLst>
 </p:sldMaster>
 </file>
@@ -817,7 +817,13 @@
       </p:grpSpPr>
       <p:sp>
         <p:nvSpPr>
-          <p:cNvPr id="2" name="Background"/>
+          <p:cNvPr id="2" name="Background">
+            <a:extLst xmlns:a="http://schemas.openxmlformats.org/drawingml/2006/main">
+              <a:ext uri="{FF2B5EF4-FFF2-40B4-BE49-F238E27FC236}">
+                <a16:creationId xmlns:a16="http://schemas.microsoft.com/office/drawing/2014/main" id="{098DEF49-9548-4FF3-8342-3E9F41BEF698}"/>
+              </a:ext>
+            </a:extLst>
+          </p:cNvPr>
           <p:cNvSpPr>
             <a:spLocks xmlns:a="http://schemas.openxmlformats.org/drawingml/2006/main" noGrp="1"/>
           </p:cNvSpPr>
@@ -848,7 +854,7 @@
           <p:nvPr/>
         </p:nvPicPr>
         <p:blipFill>
-          <a:blip xmlns:r="http://schemas.openxmlformats.org/officeDocument/2006/relationships" xmlns:a="http://schemas.openxmlformats.org/drawingml/2006/main" r:embed="R091492b2ea094fb7"/>
+          <a:blip xmlns:r="http://schemas.openxmlformats.org/officeDocument/2006/relationships" xmlns:a="http://schemas.openxmlformats.org/drawingml/2006/main" r:embed="R9f48f5b1eeed4f93"/>
           <a:stretch xmlns:a="http://schemas.openxmlformats.org/drawingml/2006/main">
             <a:fillRect l="0" t="0" r="0" b="0"/>
           </a:stretch>
@@ -872,7 +878,7 @@
           <p:nvPr/>
         </p:nvPicPr>
         <p:blipFill>
-          <a:blip xmlns:r="http://schemas.openxmlformats.org/officeDocument/2006/relationships" xmlns:a="http://schemas.openxmlformats.org/drawingml/2006/main" r:embed="Rc406c11953c64b4d"/>
+          <a:blip xmlns:r="http://schemas.openxmlformats.org/officeDocument/2006/relationships" xmlns:a="http://schemas.openxmlformats.org/drawingml/2006/main" r:embed="R37b4e0a0360745da"/>
           <a:stretch xmlns:a="http://schemas.openxmlformats.org/drawingml/2006/main">
             <a:fillRect l="0" t="0" r="0" b="0"/>
           </a:stretch>
@@ -889,7 +895,13 @@
       </p:pic>
       <p:sp>
         <p:nvSpPr>
-          <p:cNvPr id="5" name="Title"/>
+          <p:cNvPr id="5" name="Title">
+            <a:extLst xmlns:a="http://schemas.openxmlformats.org/drawingml/2006/main">
+              <a:ext uri="{FF2B5EF4-FFF2-40B4-BE49-F238E27FC236}">
+                <a16:creationId xmlns:a16="http://schemas.microsoft.com/office/drawing/2014/main" id="{91FC63E8-2947-4924-965B-137D90711140}"/>
+              </a:ext>
+            </a:extLst>
+          </p:cNvPr>
           <p:cNvSpPr>
             <a:spLocks xmlns:a="http://schemas.openxmlformats.org/drawingml/2006/main" noGrp="1"/>
           </p:cNvSpPr>
@@ -961,7 +973,13 @@
       </p:sp>
       <p:sp>
         <p:nvSpPr>
-          <p:cNvPr id="6" name="Subtitle"/>
+          <p:cNvPr id="6" name="Subtitle">
+            <a:extLst xmlns:a="http://schemas.openxmlformats.org/drawingml/2006/main">
+              <a:ext uri="{FF2B5EF4-FFF2-40B4-BE49-F238E27FC236}">
+                <a16:creationId xmlns:a16="http://schemas.microsoft.com/office/drawing/2014/main" id="{4E66A0D5-7EDC-4FC1-B79E-7FFF1C15122A}"/>
+              </a:ext>
+            </a:extLst>
+          </p:cNvPr>
           <p:cNvSpPr>
             <a:spLocks xmlns:a="http://schemas.openxmlformats.org/drawingml/2006/main" noGrp="1"/>
           </p:cNvSpPr>
@@ -1011,7 +1029,13 @@
       </p:sp>
       <p:sp>
         <p:nvSpPr>
-          <p:cNvPr id="7" name="Scope"/>
+          <p:cNvPr id="7" name="Scope">
+            <a:extLst xmlns:a="http://schemas.openxmlformats.org/drawingml/2006/main">
+              <a:ext uri="{FF2B5EF4-FFF2-40B4-BE49-F238E27FC236}">
+                <a16:creationId xmlns:a16="http://schemas.microsoft.com/office/drawing/2014/main" id="{E59BC57C-49E9-426D-8F35-8751AA9ED729}"/>
+              </a:ext>
+            </a:extLst>
+          </p:cNvPr>
           <p:cNvSpPr>
             <a:spLocks xmlns:a="http://schemas.openxmlformats.org/drawingml/2006/main" noGrp="1"/>
           </p:cNvSpPr>
@@ -1061,7 +1085,13 @@
       </p:sp>
       <p:sp>
         <p:nvSpPr>
-          <p:cNvPr id="8" name="Deck type"/>
+          <p:cNvPr id="8" name="Deck type">
+            <a:extLst xmlns:a="http://schemas.openxmlformats.org/drawingml/2006/main">
+              <a:ext uri="{FF2B5EF4-FFF2-40B4-BE49-F238E27FC236}">
+                <a16:creationId xmlns:a16="http://schemas.microsoft.com/office/drawing/2014/main" id="{D6E685BE-97BE-44B6-B5CE-C49F2750C9AD}"/>
+              </a:ext>
+            </a:extLst>
+          </p:cNvPr>
           <p:cNvSpPr>
             <a:spLocks xmlns:a="http://schemas.openxmlformats.org/drawingml/2006/main" noGrp="1"/>
           </p:cNvSpPr>
@@ -1133,7 +1163,13 @@
       </p:grpSpPr>
       <p:sp>
         <p:nvSpPr>
-          <p:cNvPr id="2" name="Background"/>
+          <p:cNvPr id="2" name="Background">
+            <a:extLst xmlns:a="http://schemas.openxmlformats.org/drawingml/2006/main">
+              <a:ext uri="{FF2B5EF4-FFF2-40B4-BE49-F238E27FC236}">
+                <a16:creationId xmlns:a16="http://schemas.microsoft.com/office/drawing/2014/main" id="{588567B5-DE60-4971-B144-CD59AF2E500E}"/>
+              </a:ext>
+            </a:extLst>
+          </p:cNvPr>
           <p:cNvSpPr>
             <a:spLocks xmlns:a="http://schemas.openxmlformats.org/drawingml/2006/main" noGrp="1"/>
           </p:cNvSpPr>
@@ -1157,7 +1193,13 @@
       </p:sp>
       <p:sp>
         <p:nvSpPr>
-          <p:cNvPr id="3" name="Diagram title"/>
+          <p:cNvPr id="3" name="Diagram title">
+            <a:extLst xmlns:a="http://schemas.openxmlformats.org/drawingml/2006/main">
+              <a:ext uri="{FF2B5EF4-FFF2-40B4-BE49-F238E27FC236}">
+                <a16:creationId xmlns:a16="http://schemas.microsoft.com/office/drawing/2014/main" id="{FEAB7C6A-75BD-4555-B69F-73228B439CC4}"/>
+              </a:ext>
+            </a:extLst>
+          </p:cNvPr>
           <p:cNvSpPr>
             <a:spLocks xmlns:a="http://schemas.openxmlformats.org/drawingml/2006/main" noGrp="1"/>
           </p:cNvSpPr>
@@ -1207,7 +1249,13 @@
       </p:sp>
       <p:sp>
         <p:nvSpPr>
-          <p:cNvPr id="4" name="Region boundary"/>
+          <p:cNvPr id="4" name="Region boundary">
+            <a:extLst xmlns:a="http://schemas.openxmlformats.org/drawingml/2006/main">
+              <a:ext uri="{FF2B5EF4-FFF2-40B4-BE49-F238E27FC236}">
+                <a16:creationId xmlns:a16="http://schemas.microsoft.com/office/drawing/2014/main" id="{838D2B49-1B9B-44A5-B744-BA481EAF1CA9}"/>
+              </a:ext>
+            </a:extLst>
+          </p:cNvPr>
           <p:cNvSpPr>
             <a:spLocks xmlns:a="http://schemas.openxmlformats.org/drawingml/2006/main" noGrp="1"/>
           </p:cNvSpPr>
@@ -1235,7 +1283,13 @@
       </p:sp>
       <p:sp>
         <p:nvSpPr>
-          <p:cNvPr id="5" name="Region boundary label"/>
+          <p:cNvPr id="5" name="Region boundary label">
+            <a:extLst xmlns:a="http://schemas.openxmlformats.org/drawingml/2006/main">
+              <a:ext uri="{FF2B5EF4-FFF2-40B4-BE49-F238E27FC236}">
+                <a16:creationId xmlns:a16="http://schemas.microsoft.com/office/drawing/2014/main" id="{C6554E1C-66F4-464D-A5E8-8434BBD82FC5}"/>
+              </a:ext>
+            </a:extLst>
+          </p:cNvPr>
           <p:cNvSpPr>
             <a:spLocks xmlns:a="http://schemas.openxmlformats.org/drawingml/2006/main" noGrp="1"/>
           </p:cNvSpPr>
@@ -1285,7 +1339,13 @@
       </p:sp>
       <p:sp>
         <p:nvSpPr>
-          <p:cNvPr id="6" name="VCN boundary"/>
+          <p:cNvPr id="6" name="VCN boundary">
+            <a:extLst xmlns:a="http://schemas.openxmlformats.org/drawingml/2006/main">
+              <a:ext uri="{FF2B5EF4-FFF2-40B4-BE49-F238E27FC236}">
+                <a16:creationId xmlns:a16="http://schemas.microsoft.com/office/drawing/2014/main" id="{187FF6D0-02A5-456F-8A71-5EF22983DE90}"/>
+              </a:ext>
+            </a:extLst>
+          </p:cNvPr>
           <p:cNvSpPr>
             <a:spLocks xmlns:a="http://schemas.openxmlformats.org/drawingml/2006/main" noGrp="1"/>
           </p:cNvSpPr>
@@ -1310,7 +1370,13 @@
       </p:sp>
       <p:sp>
         <p:nvSpPr>
-          <p:cNvPr id="7" name="VCN boundary label"/>
+          <p:cNvPr id="7" name="VCN boundary label">
+            <a:extLst xmlns:a="http://schemas.openxmlformats.org/drawingml/2006/main">
+              <a:ext uri="{FF2B5EF4-FFF2-40B4-BE49-F238E27FC236}">
+                <a16:creationId xmlns:a16="http://schemas.microsoft.com/office/drawing/2014/main" id="{9095B4D7-2CEF-4D42-9B06-110A7CE3E557}"/>
+              </a:ext>
+            </a:extLst>
+          </p:cNvPr>
           <p:cNvSpPr>
             <a:spLocks xmlns:a="http://schemas.openxmlformats.org/drawingml/2006/main" noGrp="1"/>
           </p:cNvSpPr>
@@ -1360,14 +1426,14 @@
       </p:sp>
       <p:pic>
         <p:nvPicPr>
-          <p:cNvPr id="75" name="VCN badge"/>
+          <p:cNvPr id="193" name="VCN badge"/>
           <p:cNvPicPr>
             <a:picLocks xmlns:a="http://schemas.openxmlformats.org/drawingml/2006/main" noChangeAspect="1"/>
           </p:cNvPicPr>
           <p:nvPr/>
         </p:nvPicPr>
         <p:blipFill>
-          <a:blip xmlns:r="http://schemas.openxmlformats.org/officeDocument/2006/relationships" xmlns:a="http://schemas.openxmlformats.org/drawingml/2006/main" r:embed="R4434b164381740c5"/>
+          <a:blip xmlns:r="http://schemas.openxmlformats.org/officeDocument/2006/relationships" xmlns:a="http://schemas.openxmlformats.org/drawingml/2006/main" r:embed="Rc556968a848841f5"/>
           <a:stretch xmlns:a="http://schemas.openxmlformats.org/drawingml/2006/main">
             <a:fillRect l="0" t="0" r="0" b="0"/>
           </a:stretch>
@@ -1384,7 +1450,13 @@
       </p:pic>
       <p:sp>
         <p:nvSpPr>
-          <p:cNvPr id="9" name="Subnet 1"/>
+          <p:cNvPr id="9" name="Subnet 1">
+            <a:extLst xmlns:a="http://schemas.openxmlformats.org/drawingml/2006/main">
+              <a:ext uri="{FF2B5EF4-FFF2-40B4-BE49-F238E27FC236}">
+                <a16:creationId xmlns:a16="http://schemas.microsoft.com/office/drawing/2014/main" id="{A3DD71F5-1B38-47B5-B8CE-BA8AF0C65353}"/>
+              </a:ext>
+            </a:extLst>
+          </p:cNvPr>
           <p:cNvSpPr>
             <a:spLocks xmlns:a="http://schemas.openxmlformats.org/drawingml/2006/main" noGrp="1"/>
           </p:cNvSpPr>
@@ -1409,7 +1481,13 @@
       </p:sp>
       <p:sp>
         <p:nvSpPr>
-          <p:cNvPr id="10" name="Subnet 1 label"/>
+          <p:cNvPr id="10" name="Subnet 1 label">
+            <a:extLst xmlns:a="http://schemas.openxmlformats.org/drawingml/2006/main">
+              <a:ext uri="{FF2B5EF4-FFF2-40B4-BE49-F238E27FC236}">
+                <a16:creationId xmlns:a16="http://schemas.microsoft.com/office/drawing/2014/main" id="{25FAB66E-E77F-4D83-AA9D-A6B287D37F79}"/>
+              </a:ext>
+            </a:extLst>
+          </p:cNvPr>
           <p:cNvSpPr>
             <a:spLocks xmlns:a="http://schemas.openxmlformats.org/drawingml/2006/main" noGrp="1"/>
           </p:cNvSpPr>
@@ -1459,14 +1537,14 @@
       </p:sp>
       <p:pic>
         <p:nvPicPr>
-          <p:cNvPr id="78" name="Subnet 1 route table badge"/>
+          <p:cNvPr id="196" name="Subnet 1 route table badge"/>
           <p:cNvPicPr>
             <a:picLocks xmlns:a="http://schemas.openxmlformats.org/drawingml/2006/main" noChangeAspect="1"/>
           </p:cNvPicPr>
           <p:nvPr/>
         </p:nvPicPr>
         <p:blipFill>
-          <a:blip xmlns:r="http://schemas.openxmlformats.org/officeDocument/2006/relationships" xmlns:a="http://schemas.openxmlformats.org/drawingml/2006/main" r:embed="R9a7e5948d7cb46fb"/>
+          <a:blip xmlns:r="http://schemas.openxmlformats.org/officeDocument/2006/relationships" xmlns:a="http://schemas.openxmlformats.org/drawingml/2006/main" r:embed="Re05f602d20f5443d"/>
           <a:stretch xmlns:a="http://schemas.openxmlformats.org/drawingml/2006/main">
             <a:fillRect l="0" t="0" r="0" b="0"/>
           </a:stretch>
@@ -1483,14 +1561,14 @@
       </p:pic>
       <p:pic>
         <p:nvPicPr>
-          <p:cNvPr id="79" name="Subnet 1 security list badge"/>
+          <p:cNvPr id="197" name="Subnet 1 security list badge"/>
           <p:cNvPicPr>
             <a:picLocks xmlns:a="http://schemas.openxmlformats.org/drawingml/2006/main" noChangeAspect="1"/>
           </p:cNvPicPr>
           <p:nvPr/>
         </p:nvPicPr>
         <p:blipFill>
-          <a:blip xmlns:r="http://schemas.openxmlformats.org/officeDocument/2006/relationships" xmlns:a="http://schemas.openxmlformats.org/drawingml/2006/main" r:embed="Re26c10c291e44f0f"/>
+          <a:blip xmlns:r="http://schemas.openxmlformats.org/officeDocument/2006/relationships" xmlns:a="http://schemas.openxmlformats.org/drawingml/2006/main" r:embed="Rd4e7266ca7f341b6"/>
           <a:stretch xmlns:a="http://schemas.openxmlformats.org/drawingml/2006/main">
             <a:fillRect l="0" t="0" r="0" b="0"/>
           </a:stretch>
@@ -1507,14 +1585,14 @@
       </p:pic>
       <p:pic>
         <p:nvPicPr>
-          <p:cNvPr id="80" name="Icon User"/>
+          <p:cNvPr id="198" name="Icon User"/>
           <p:cNvPicPr>
             <a:picLocks xmlns:a="http://schemas.openxmlformats.org/drawingml/2006/main" noChangeAspect="1"/>
           </p:cNvPicPr>
           <p:nvPr/>
         </p:nvPicPr>
         <p:blipFill>
-          <a:blip xmlns:r="http://schemas.openxmlformats.org/officeDocument/2006/relationships" xmlns:a="http://schemas.openxmlformats.org/drawingml/2006/main" r:embed="R8a95fa06a3204906"/>
+          <a:blip xmlns:r="http://schemas.openxmlformats.org/officeDocument/2006/relationships" xmlns:a="http://schemas.openxmlformats.org/drawingml/2006/main" r:embed="R5b54b0a975a34191"/>
           <a:stretch xmlns:a="http://schemas.openxmlformats.org/drawingml/2006/main">
             <a:fillRect l="0" t="0" r="0" b="0"/>
           </a:stretch>
@@ -1531,7 +1609,13 @@
       </p:pic>
       <p:sp>
         <p:nvSpPr>
-          <p:cNvPr id="14" name="Label User"/>
+          <p:cNvPr id="14" name="Label User">
+            <a:extLst xmlns:a="http://schemas.openxmlformats.org/drawingml/2006/main">
+              <a:ext uri="{FF2B5EF4-FFF2-40B4-BE49-F238E27FC236}">
+                <a16:creationId xmlns:a16="http://schemas.microsoft.com/office/drawing/2014/main" id="{939EF022-0630-409A-8560-ACA9210020A0}"/>
+              </a:ext>
+            </a:extLst>
+          </p:cNvPr>
           <p:cNvSpPr>
             <a:spLocks xmlns:a="http://schemas.openxmlformats.org/drawingml/2006/main" noGrp="1"/>
           </p:cNvSpPr>
@@ -1563,8 +1647,8 @@
                   <a:srgbClr val="164E63"/>
                 </a:solidFill>
                 <a:latin typeface="Aptos"/>
-                <a:ea typeface="Malgun Gothic"/>
-                <a:cs typeface="Malgun Gothic"/>
+                <a:ea typeface="Aptos"/>
+                <a:cs typeface="Aptos"/>
               </a:defRPr>
             </a:pPr>
             <a:r>
@@ -1573,8 +1657,8 @@
                   <a:srgbClr val="164E63"/>
                 </a:solidFill>
                 <a:latin typeface="Aptos"/>
-                <a:ea typeface="Malgun Gothic"/>
-                <a:cs typeface="Malgun Gothic"/>
+                <a:ea typeface="Aptos"/>
+                <a:cs typeface="Aptos"/>
               </a:rPr>
               <a:t>User Browser</a:t>
             </a:r>
@@ -1584,14 +1668,14 @@
       </p:sp>
       <p:pic>
         <p:nvPicPr>
-          <p:cNvPr id="82" name="Icon IGW"/>
+          <p:cNvPr id="200" name="Icon IGW"/>
           <p:cNvPicPr>
             <a:picLocks xmlns:a="http://schemas.openxmlformats.org/drawingml/2006/main" noChangeAspect="1"/>
           </p:cNvPicPr>
           <p:nvPr/>
         </p:nvPicPr>
         <p:blipFill>
-          <a:blip xmlns:r="http://schemas.openxmlformats.org/officeDocument/2006/relationships" xmlns:a="http://schemas.openxmlformats.org/drawingml/2006/main" r:embed="R05ca07b1b3824578"/>
+          <a:blip xmlns:r="http://schemas.openxmlformats.org/officeDocument/2006/relationships" xmlns:a="http://schemas.openxmlformats.org/drawingml/2006/main" r:embed="R02ff1fe46a94451d"/>
           <a:stretch xmlns:a="http://schemas.openxmlformats.org/drawingml/2006/main">
             <a:fillRect l="0" t="0" r="0" b="0"/>
           </a:stretch>
@@ -1608,7 +1692,13 @@
       </p:pic>
       <p:sp>
         <p:nvSpPr>
-          <p:cNvPr id="16" name="Label IGW"/>
+          <p:cNvPr id="16" name="Label IGW">
+            <a:extLst xmlns:a="http://schemas.openxmlformats.org/drawingml/2006/main">
+              <a:ext uri="{FF2B5EF4-FFF2-40B4-BE49-F238E27FC236}">
+                <a16:creationId xmlns:a16="http://schemas.microsoft.com/office/drawing/2014/main" id="{BF9C95A3-8F87-4CD6-B378-6BF68D4EF34D}"/>
+              </a:ext>
+            </a:extLst>
+          </p:cNvPr>
           <p:cNvSpPr>
             <a:spLocks xmlns:a="http://schemas.openxmlformats.org/drawingml/2006/main" noGrp="1"/>
           </p:cNvSpPr>
@@ -1640,8 +1730,8 @@
                   <a:srgbClr val="164E63"/>
                 </a:solidFill>
                 <a:latin typeface="Aptos"/>
-                <a:ea typeface="Malgun Gothic"/>
-                <a:cs typeface="Malgun Gothic"/>
+                <a:ea typeface="Aptos"/>
+                <a:cs typeface="Aptos"/>
               </a:defRPr>
             </a:pPr>
             <a:r>
@@ -1650,8 +1740,8 @@
                   <a:srgbClr val="164E63"/>
                 </a:solidFill>
                 <a:latin typeface="Aptos"/>
-                <a:ea typeface="Malgun Gothic"/>
-                <a:cs typeface="Malgun Gothic"/>
+                <a:ea typeface="Aptos"/>
+                <a:cs typeface="Aptos"/>
               </a:rPr>
               <a:t>IGW</a:t>
             </a:r>
@@ -1661,14 +1751,14 @@
       </p:sp>
       <p:pic>
         <p:nvPicPr>
-          <p:cNvPr id="84" name="Icon pixel-panic-api-prod-01"/>
+          <p:cNvPr id="202" name="Icon pixel-panic-api-prod-01"/>
           <p:cNvPicPr>
             <a:picLocks xmlns:a="http://schemas.openxmlformats.org/drawingml/2006/main" noChangeAspect="1"/>
           </p:cNvPicPr>
           <p:nvPr/>
         </p:nvPicPr>
         <p:blipFill>
-          <a:blip xmlns:r="http://schemas.openxmlformats.org/officeDocument/2006/relationships" xmlns:a="http://schemas.openxmlformats.org/drawingml/2006/main" r:embed="R036237e3022a4da6"/>
+          <a:blip xmlns:r="http://schemas.openxmlformats.org/officeDocument/2006/relationships" xmlns:a="http://schemas.openxmlformats.org/drawingml/2006/main" r:embed="R0801dfc19708497a"/>
           <a:stretch xmlns:a="http://schemas.openxmlformats.org/drawingml/2006/main">
             <a:fillRect l="0" t="0" r="0" b="0"/>
           </a:stretch>
@@ -1685,7 +1775,13 @@
       </p:pic>
       <p:sp>
         <p:nvSpPr>
-          <p:cNvPr id="20" name="Label pixel-panic-api-prod-01"/>
+          <p:cNvPr id="20" name="Label pixel-panic-api-prod-01">
+            <a:extLst xmlns:a="http://schemas.openxmlformats.org/drawingml/2006/main">
+              <a:ext uri="{FF2B5EF4-FFF2-40B4-BE49-F238E27FC236}">
+                <a16:creationId xmlns:a16="http://schemas.microsoft.com/office/drawing/2014/main" id="{A63DAF34-28A9-45FA-B89B-294E1B48936F}"/>
+              </a:ext>
+            </a:extLst>
+          </p:cNvPr>
           <p:cNvSpPr>
             <a:spLocks xmlns:a="http://schemas.openxmlformats.org/drawingml/2006/main" noGrp="1"/>
           </p:cNvSpPr>
@@ -1717,8 +1813,8 @@
                   <a:srgbClr val="164E63"/>
                 </a:solidFill>
                 <a:latin typeface="Aptos"/>
-                <a:ea typeface="Malgun Gothic"/>
-                <a:cs typeface="Malgun Gothic"/>
+                <a:ea typeface="Aptos"/>
+                <a:cs typeface="Aptos"/>
               </a:defRPr>
             </a:pPr>
             <a:r>
@@ -1727,8 +1823,8 @@
                   <a:srgbClr val="164E63"/>
                 </a:solidFill>
                 <a:latin typeface="Aptos"/>
-                <a:ea typeface="Malgun Gothic"/>
-                <a:cs typeface="Malgun Gothic"/>
+                <a:ea typeface="Aptos"/>
+                <a:cs typeface="Aptos"/>
               </a:rPr>
               <a:t>Compute VM</a:t>
             </a:r>
@@ -1738,7 +1834,13 @@
       </p:sp>
       <p:sp>
         <p:nvSpPr>
-          <p:cNvPr id="21" name="Legend"/>
+          <p:cNvPr id="21" name="Legend">
+            <a:extLst xmlns:a="http://schemas.openxmlformats.org/drawingml/2006/main">
+              <a:ext uri="{FF2B5EF4-FFF2-40B4-BE49-F238E27FC236}">
+                <a16:creationId xmlns:a16="http://schemas.microsoft.com/office/drawing/2014/main" id="{4FEF5851-A8BE-47E8-A714-DACB764E7D24}"/>
+              </a:ext>
+            </a:extLst>
+          </p:cNvPr>
           <p:cNvSpPr>
             <a:spLocks xmlns:a="http://schemas.openxmlformats.org/drawingml/2006/main" noGrp="1"/>
           </p:cNvSpPr>
@@ -1788,7 +1890,13 @@
       </p:sp>
       <p:sp>
         <p:nvSpPr>
-          <p:cNvPr id="29" name="User Browser boundary"/>
+          <p:cNvPr id="29" name="User Browser boundary">
+            <a:extLst xmlns:a="http://schemas.openxmlformats.org/drawingml/2006/main">
+              <a:ext uri="{FF2B5EF4-FFF2-40B4-BE49-F238E27FC236}">
+                <a16:creationId xmlns:a16="http://schemas.microsoft.com/office/drawing/2014/main" id="{4248DC51-E180-4035-A197-11FB0787CEF1}"/>
+              </a:ext>
+            </a:extLst>
+          </p:cNvPr>
           <p:cNvSpPr>
             <a:spLocks xmlns:a="http://schemas.openxmlformats.org/drawingml/2006/main" noGrp="1"/>
           </p:cNvSpPr>
@@ -1815,7 +1923,13 @@
       </p:sp>
       <p:sp>
         <p:nvSpPr>
-          <p:cNvPr id="30" name="Vercel Production boundary"/>
+          <p:cNvPr id="30" name="Vercel Production boundary">
+            <a:extLst xmlns:a="http://schemas.openxmlformats.org/drawingml/2006/main">
+              <a:ext uri="{FF2B5EF4-FFF2-40B4-BE49-F238E27FC236}">
+                <a16:creationId xmlns:a16="http://schemas.microsoft.com/office/drawing/2014/main" id="{B96A9FEC-7318-4FAE-9F08-42DD17830993}"/>
+              </a:ext>
+            </a:extLst>
+          </p:cNvPr>
           <p:cNvSpPr>
             <a:spLocks xmlns:a="http://schemas.openxmlformats.org/drawingml/2006/main" noGrp="1"/>
           </p:cNvSpPr>
@@ -1844,7 +1958,13 @@
       </p:sp>
       <p:sp>
         <p:nvSpPr>
-          <p:cNvPr id="31" name="Vercel cloud badge"/>
+          <p:cNvPr id="31" name="Vercel cloud badge">
+            <a:extLst xmlns:a="http://schemas.openxmlformats.org/drawingml/2006/main">
+              <a:ext uri="{FF2B5EF4-FFF2-40B4-BE49-F238E27FC236}">
+                <a16:creationId xmlns:a16="http://schemas.microsoft.com/office/drawing/2014/main" id="{DE45922B-E580-4840-BD23-99238EDC86E8}"/>
+              </a:ext>
+            </a:extLst>
+          </p:cNvPr>
           <p:cNvSpPr>
             <a:spLocks xmlns:a="http://schemas.openxmlformats.org/drawingml/2006/main" noGrp="1"/>
           </p:cNvSpPr>
@@ -1871,7 +1991,13 @@
       </p:sp>
       <p:sp>
         <p:nvSpPr>
-          <p:cNvPr id="32" name="Vercel title"/>
+          <p:cNvPr id="32" name="Vercel title">
+            <a:extLst xmlns:a="http://schemas.openxmlformats.org/drawingml/2006/main">
+              <a:ext uri="{FF2B5EF4-FFF2-40B4-BE49-F238E27FC236}">
+                <a16:creationId xmlns:a16="http://schemas.microsoft.com/office/drawing/2014/main" id="{EB1156A2-BFDE-4DF6-A031-EFD87BC147B9}"/>
+              </a:ext>
+            </a:extLst>
+          </p:cNvPr>
           <p:cNvSpPr>
             <a:spLocks xmlns:a="http://schemas.openxmlformats.org/drawingml/2006/main" noGrp="1"/>
           </p:cNvSpPr>
@@ -1896,6 +2022,7 @@
           <a:lstStyle xmlns:a="http://schemas.openxmlformats.org/drawingml/2006/main"/>
           <a:p xmlns:a="http://schemas.openxmlformats.org/drawingml/2006/main">
             <a:pPr algn="l">
+              <a:buNone/>
               <a:defRPr sz="1425" b="1">
                 <a:solidFill>
                   <a:srgbClr val="164E63"/>
@@ -1915,7 +2042,13 @@
       </p:sp>
       <p:sp>
         <p:nvSpPr>
-          <p:cNvPr id="33" name="Next.js application"/>
+          <p:cNvPr id="33" name="Next.js application">
+            <a:extLst xmlns:a="http://schemas.openxmlformats.org/drawingml/2006/main">
+              <a:ext uri="{FF2B5EF4-FFF2-40B4-BE49-F238E27FC236}">
+                <a16:creationId xmlns:a16="http://schemas.microsoft.com/office/drawing/2014/main" id="{3317CAC6-74BE-4370-A222-60BD7F3F3330}"/>
+              </a:ext>
+            </a:extLst>
+          </p:cNvPr>
           <p:cNvSpPr>
             <a:spLocks xmlns:a="http://schemas.openxmlformats.org/drawingml/2006/main" noGrp="1"/>
           </p:cNvSpPr>
@@ -1944,7 +2077,13 @@
       </p:sp>
       <p:sp>
         <p:nvSpPr>
-          <p:cNvPr id="34" name="Next.js application title"/>
+          <p:cNvPr id="34" name="Next.js application title">
+            <a:extLst xmlns:a="http://schemas.openxmlformats.org/drawingml/2006/main">
+              <a:ext uri="{FF2B5EF4-FFF2-40B4-BE49-F238E27FC236}">
+                <a16:creationId xmlns:a16="http://schemas.microsoft.com/office/drawing/2014/main" id="{EB485A56-5EF2-43F2-B60A-683E5F90A6F8}"/>
+              </a:ext>
+            </a:extLst>
+          </p:cNvPr>
           <p:cNvSpPr>
             <a:spLocks xmlns:a="http://schemas.openxmlformats.org/drawingml/2006/main" noGrp="1"/>
           </p:cNvSpPr>
@@ -1969,6 +2108,7 @@
           <a:lstStyle xmlns:a="http://schemas.openxmlformats.org/drawingml/2006/main"/>
           <a:p xmlns:a="http://schemas.openxmlformats.org/drawingml/2006/main">
             <a:pPr algn="l">
+              <a:buNone/>
               <a:defRPr sz="1350" b="1">
                 <a:solidFill>
                   <a:srgbClr val="075985"/>
@@ -1988,7 +2128,13 @@
       </p:sp>
       <p:sp>
         <p:nvSpPr>
-          <p:cNvPr id="35" name="Next.js application detail"/>
+          <p:cNvPr id="35" name="Next.js application detail">
+            <a:extLst xmlns:a="http://schemas.openxmlformats.org/drawingml/2006/main">
+              <a:ext uri="{FF2B5EF4-FFF2-40B4-BE49-F238E27FC236}">
+                <a16:creationId xmlns:a16="http://schemas.microsoft.com/office/drawing/2014/main" id="{0BFD8329-0BBD-4ACB-A2F1-3413C0CBE49E}"/>
+              </a:ext>
+            </a:extLst>
+          </p:cNvPr>
           <p:cNvSpPr>
             <a:spLocks xmlns:a="http://schemas.openxmlformats.org/drawingml/2006/main" noGrp="1"/>
           </p:cNvSpPr>
@@ -2013,6 +2159,7 @@
           <a:lstStyle xmlns:a="http://schemas.openxmlformats.org/drawingml/2006/main"/>
           <a:p xmlns:a="http://schemas.openxmlformats.org/drawingml/2006/main">
             <a:pPr algn="l">
+              <a:buNone/>
               <a:defRPr sz="1125" b="0">
                 <a:solidFill>
                   <a:srgbClr val="0C4A6E"/>
@@ -2032,7 +2179,13 @@
       </p:sp>
       <p:sp>
         <p:nvSpPr>
-          <p:cNvPr id="36" name="Plan server route"/>
+          <p:cNvPr id="36" name="Plan server route">
+            <a:extLst xmlns:a="http://schemas.openxmlformats.org/drawingml/2006/main">
+              <a:ext uri="{FF2B5EF4-FFF2-40B4-BE49-F238E27FC236}">
+                <a16:creationId xmlns:a16="http://schemas.microsoft.com/office/drawing/2014/main" id="{367760C6-B6F3-4551-9D49-102CFC2C67B9}"/>
+              </a:ext>
+            </a:extLst>
+          </p:cNvPr>
           <p:cNvSpPr>
             <a:spLocks xmlns:a="http://schemas.openxmlformats.org/drawingml/2006/main" noGrp="1"/>
           </p:cNvSpPr>
@@ -2061,7 +2214,13 @@
       </p:sp>
       <p:sp>
         <p:nvSpPr>
-          <p:cNvPr id="37" name="Plan server route title"/>
+          <p:cNvPr id="37" name="Plan server route title">
+            <a:extLst xmlns:a="http://schemas.openxmlformats.org/drawingml/2006/main">
+              <a:ext uri="{FF2B5EF4-FFF2-40B4-BE49-F238E27FC236}">
+                <a16:creationId xmlns:a16="http://schemas.microsoft.com/office/drawing/2014/main" id="{8C16CA28-1DFF-4976-B83F-31AF36CB23CA}"/>
+              </a:ext>
+            </a:extLst>
+          </p:cNvPr>
           <p:cNvSpPr>
             <a:spLocks xmlns:a="http://schemas.openxmlformats.org/drawingml/2006/main" noGrp="1"/>
           </p:cNvSpPr>
@@ -2086,6 +2245,7 @@
           <a:lstStyle xmlns:a="http://schemas.openxmlformats.org/drawingml/2006/main"/>
           <a:p xmlns:a="http://schemas.openxmlformats.org/drawingml/2006/main">
             <a:pPr algn="l">
+              <a:buNone/>
               <a:defRPr sz="1350" b="1">
                 <a:solidFill>
                   <a:srgbClr val="5B21B6"/>
@@ -2098,14 +2258,20 @@
                   <a:srgbClr val="5B21B6"/>
                 </a:solidFill>
               </a:rPr>
-              <a:t>/api/plan Server Route</a:t>
-            </a:r>
-          </a:p>
-        </p:txBody>
-      </p:sp>
-      <p:sp>
-        <p:nvSpPr>
-          <p:cNvPr id="38" name="Plan server route detail"/>
+              <a:t>/api/dialogue Route</a:t>
+            </a:r>
+          </a:p>
+        </p:txBody>
+      </p:sp>
+      <p:sp>
+        <p:nvSpPr>
+          <p:cNvPr id="38" name="Plan server route detail">
+            <a:extLst xmlns:a="http://schemas.openxmlformats.org/drawingml/2006/main">
+              <a:ext uri="{FF2B5EF4-FFF2-40B4-BE49-F238E27FC236}">
+                <a16:creationId xmlns:a16="http://schemas.microsoft.com/office/drawing/2014/main" id="{1DF0900A-A28E-4C7E-86F3-C8B4D9722F6B}"/>
+              </a:ext>
+            </a:extLst>
+          </p:cNvPr>
           <p:cNvSpPr>
             <a:spLocks xmlns:a="http://schemas.openxmlformats.org/drawingml/2006/main" noGrp="1"/>
           </p:cNvSpPr>
@@ -2130,6 +2296,7 @@
           <a:lstStyle xmlns:a="http://schemas.openxmlformats.org/drawingml/2006/main"/>
           <a:p xmlns:a="http://schemas.openxmlformats.org/drawingml/2006/main">
             <a:pPr algn="l">
+              <a:buNone/>
               <a:defRPr sz="1050" b="0">
                 <a:solidFill>
                   <a:srgbClr val="5B21B6"/>
@@ -2142,14 +2309,20 @@
                   <a:srgbClr val="5B21B6"/>
                 </a:solidFill>
               </a:rPr>
-              <a:t>Validation proxy · request ID</a:t>
-            </a:r>
-          </a:p>
-        </p:txBody>
-      </p:sp>
-      <p:sp>
-        <p:nvSpPr>
-          <p:cNvPr id="39" name="Vercel server-only secret"/>
+              <a:t>Dialogue proxy · request ID</a:t>
+            </a:r>
+          </a:p>
+        </p:txBody>
+      </p:sp>
+      <p:sp>
+        <p:nvSpPr>
+          <p:cNvPr id="39" name="Vercel server-only secret">
+            <a:extLst xmlns:a="http://schemas.openxmlformats.org/drawingml/2006/main">
+              <a:ext uri="{FF2B5EF4-FFF2-40B4-BE49-F238E27FC236}">
+                <a16:creationId xmlns:a16="http://schemas.microsoft.com/office/drawing/2014/main" id="{BDADCC35-334F-4480-A65F-0A23A96A0C09}"/>
+              </a:ext>
+            </a:extLst>
+          </p:cNvPr>
           <p:cNvSpPr>
             <a:spLocks xmlns:a="http://schemas.openxmlformats.org/drawingml/2006/main" noGrp="1"/>
           </p:cNvSpPr>
@@ -2178,7 +2351,13 @@
       </p:sp>
       <p:sp>
         <p:nvSpPr>
-          <p:cNvPr id="40" name="Vercel server-only secret label"/>
+          <p:cNvPr id="40" name="Vercel server-only secret label">
+            <a:extLst xmlns:a="http://schemas.openxmlformats.org/drawingml/2006/main">
+              <a:ext uri="{FF2B5EF4-FFF2-40B4-BE49-F238E27FC236}">
+                <a16:creationId xmlns:a16="http://schemas.microsoft.com/office/drawing/2014/main" id="{151FFBA0-92D5-407D-9967-24630CABFC34}"/>
+              </a:ext>
+            </a:extLst>
+          </p:cNvPr>
           <p:cNvSpPr>
             <a:spLocks xmlns:a="http://schemas.openxmlformats.org/drawingml/2006/main" noGrp="1"/>
           </p:cNvSpPr>
@@ -2203,6 +2382,7 @@
           <a:lstStyle xmlns:a="http://schemas.openxmlformats.org/drawingml/2006/main"/>
           <a:p xmlns:a="http://schemas.openxmlformats.org/drawingml/2006/main">
             <a:pPr algn="ctr">
+              <a:buNone/>
               <a:defRPr sz="975" b="1">
                 <a:solidFill>
                   <a:srgbClr val="6D28D9"/>
@@ -2222,7 +2402,13 @@
       </p:sp>
       <p:sp>
         <p:nvSpPr>
-          <p:cNvPr id="41" name="LOCAL fallback"/>
+          <p:cNvPr id="41" name="LOCAL fallback">
+            <a:extLst xmlns:a="http://schemas.openxmlformats.org/drawingml/2006/main">
+              <a:ext uri="{FF2B5EF4-FFF2-40B4-BE49-F238E27FC236}">
+                <a16:creationId xmlns:a16="http://schemas.microsoft.com/office/drawing/2014/main" id="{440E013D-F816-4628-AA2A-448FF377C4CC}"/>
+              </a:ext>
+            </a:extLst>
+          </p:cNvPr>
           <p:cNvSpPr>
             <a:spLocks xmlns:a="http://schemas.openxmlformats.org/drawingml/2006/main" noGrp="1"/>
           </p:cNvSpPr>
@@ -2251,7 +2437,13 @@
       </p:sp>
       <p:sp>
         <p:nvSpPr>
-          <p:cNvPr id="42" name="LOCAL fallback title"/>
+          <p:cNvPr id="42" name="LOCAL fallback title">
+            <a:extLst xmlns:a="http://schemas.openxmlformats.org/drawingml/2006/main">
+              <a:ext uri="{FF2B5EF4-FFF2-40B4-BE49-F238E27FC236}">
+                <a16:creationId xmlns:a16="http://schemas.microsoft.com/office/drawing/2014/main" id="{92F1BC17-28CA-4449-AD19-A75078E5EB65}"/>
+              </a:ext>
+            </a:extLst>
+          </p:cNvPr>
           <p:cNvSpPr>
             <a:spLocks xmlns:a="http://schemas.openxmlformats.org/drawingml/2006/main" noGrp="1"/>
           </p:cNvSpPr>
@@ -2276,6 +2468,7 @@
           <a:lstStyle xmlns:a="http://schemas.openxmlformats.org/drawingml/2006/main"/>
           <a:p xmlns:a="http://schemas.openxmlformats.org/drawingml/2006/main">
             <a:pPr algn="l">
+              <a:buNone/>
               <a:defRPr sz="1350" b="1">
                 <a:solidFill>
                   <a:srgbClr val="9A3412"/>
@@ -2295,7 +2488,13 @@
       </p:sp>
       <p:sp>
         <p:nvSpPr>
-          <p:cNvPr id="43" name="LOCAL fallback detail"/>
+          <p:cNvPr id="43" name="LOCAL fallback detail">
+            <a:extLst xmlns:a="http://schemas.openxmlformats.org/drawingml/2006/main">
+              <a:ext uri="{FF2B5EF4-FFF2-40B4-BE49-F238E27FC236}">
+                <a16:creationId xmlns:a16="http://schemas.microsoft.com/office/drawing/2014/main" id="{B1773102-2DC0-4EF7-B89A-FA60451ABD50}"/>
+              </a:ext>
+            </a:extLst>
+          </p:cNvPr>
           <p:cNvSpPr>
             <a:spLocks xmlns:a="http://schemas.openxmlformats.org/drawingml/2006/main" noGrp="1"/>
           </p:cNvSpPr>
@@ -2320,6 +2519,7 @@
           <a:lstStyle xmlns:a="http://schemas.openxmlformats.org/drawingml/2006/main"/>
           <a:p xmlns:a="http://schemas.openxmlformats.org/drawingml/2006/main">
             <a:pPr algn="l">
+              <a:buNone/>
               <a:defRPr sz="975" b="0">
                 <a:solidFill>
                   <a:srgbClr val="9A3412"/>
@@ -2332,11 +2532,12 @@
                   <a:srgbClr val="9A3412"/>
                 </a:solidFill>
               </a:rPr>
-              <a:t>Same response schema</a:t>
-            </a:r>
-          </a:p>
-          <a:p xmlns:a="http://schemas.openxmlformats.org/drawingml/2006/main">
-            <a:pPr algn="l">
+              <a:t>Static dialogue fallback</a:t>
+            </a:r>
+          </a:p>
+          <a:p xmlns:a="http://schemas.openxmlformats.org/drawingml/2006/main">
+            <a:pPr algn="l">
+              <a:buNone/>
               <a:defRPr sz="975" b="0">
                 <a:solidFill>
                   <a:srgbClr val="9A3412"/>
@@ -2356,7 +2557,13 @@
       </p:sp>
       <p:sp>
         <p:nvSpPr>
-          <p:cNvPr id="44" name="Compute VM host boundary"/>
+          <p:cNvPr id="44" name="Compute VM host boundary">
+            <a:extLst xmlns:a="http://schemas.openxmlformats.org/drawingml/2006/main">
+              <a:ext uri="{FF2B5EF4-FFF2-40B4-BE49-F238E27FC236}">
+                <a16:creationId xmlns:a16="http://schemas.microsoft.com/office/drawing/2014/main" id="{529A7B3E-9AE7-4046-9CB2-027732D26709}"/>
+              </a:ext>
+            </a:extLst>
+          </p:cNvPr>
           <p:cNvSpPr>
             <a:spLocks xmlns:a="http://schemas.openxmlformats.org/drawingml/2006/main" noGrp="1"/>
           </p:cNvSpPr>
@@ -2383,7 +2590,13 @@
       </p:sp>
       <p:sp>
         <p:nvSpPr>
-          <p:cNvPr id="45" name="Compute VM name"/>
+          <p:cNvPr id="45" name="Compute VM name">
+            <a:extLst xmlns:a="http://schemas.openxmlformats.org/drawingml/2006/main">
+              <a:ext uri="{FF2B5EF4-FFF2-40B4-BE49-F238E27FC236}">
+                <a16:creationId xmlns:a16="http://schemas.microsoft.com/office/drawing/2014/main" id="{1064EDEB-C5AB-42D7-ACA4-2F218C833C6D}"/>
+              </a:ext>
+            </a:extLst>
+          </p:cNvPr>
           <p:cNvSpPr>
             <a:spLocks xmlns:a="http://schemas.openxmlformats.org/drawingml/2006/main" noGrp="1"/>
           </p:cNvSpPr>
@@ -2408,6 +2621,7 @@
           <a:lstStyle xmlns:a="http://schemas.openxmlformats.org/drawingml/2006/main"/>
           <a:p xmlns:a="http://schemas.openxmlformats.org/drawingml/2006/main">
             <a:pPr algn="l">
+              <a:buNone/>
               <a:defRPr sz="1275" b="1">
                 <a:solidFill>
                   <a:srgbClr val="164E63"/>
@@ -2427,7 +2641,13 @@
       </p:sp>
       <p:sp>
         <p:nvSpPr>
-          <p:cNvPr id="46" name="Compute VM host label"/>
+          <p:cNvPr id="46" name="Compute VM host label">
+            <a:extLst xmlns:a="http://schemas.openxmlformats.org/drawingml/2006/main">
+              <a:ext uri="{FF2B5EF4-FFF2-40B4-BE49-F238E27FC236}">
+                <a16:creationId xmlns:a16="http://schemas.microsoft.com/office/drawing/2014/main" id="{4A3BBDC2-CB67-4576-BE68-82C44D42E900}"/>
+              </a:ext>
+            </a:extLst>
+          </p:cNvPr>
           <p:cNvSpPr>
             <a:spLocks xmlns:a="http://schemas.openxmlformats.org/drawingml/2006/main" noGrp="1"/>
           </p:cNvSpPr>
@@ -2452,6 +2672,7 @@
           <a:lstStyle xmlns:a="http://schemas.openxmlformats.org/drawingml/2006/main"/>
           <a:p xmlns:a="http://schemas.openxmlformats.org/drawingml/2006/main">
             <a:pPr algn="l">
+              <a:buNone/>
               <a:defRPr sz="975" b="0">
                 <a:solidFill>
                   <a:srgbClr val="475569"/>
@@ -2471,7 +2692,13 @@
       </p:sp>
       <p:sp>
         <p:nvSpPr>
-          <p:cNvPr id="47" name="Host controls"/>
+          <p:cNvPr id="47" name="Host controls">
+            <a:extLst xmlns:a="http://schemas.openxmlformats.org/drawingml/2006/main">
+              <a:ext uri="{FF2B5EF4-FFF2-40B4-BE49-F238E27FC236}">
+                <a16:creationId xmlns:a16="http://schemas.microsoft.com/office/drawing/2014/main" id="{0BDF05CC-97FA-4E28-AAAA-32000A0BF95A}"/>
+              </a:ext>
+            </a:extLst>
+          </p:cNvPr>
           <p:cNvSpPr>
             <a:spLocks xmlns:a="http://schemas.openxmlformats.org/drawingml/2006/main" noGrp="1"/>
           </p:cNvSpPr>
@@ -2500,7 +2727,13 @@
       </p:sp>
       <p:sp>
         <p:nvSpPr>
-          <p:cNvPr id="48" name="Host controls label"/>
+          <p:cNvPr id="48" name="Host controls label">
+            <a:extLst xmlns:a="http://schemas.openxmlformats.org/drawingml/2006/main">
+              <a:ext uri="{FF2B5EF4-FFF2-40B4-BE49-F238E27FC236}">
+                <a16:creationId xmlns:a16="http://schemas.microsoft.com/office/drawing/2014/main" id="{27601681-88AA-48FC-865A-7DA681869D00}"/>
+              </a:ext>
+            </a:extLst>
+          </p:cNvPr>
           <p:cNvSpPr>
             <a:spLocks xmlns:a="http://schemas.openxmlformats.org/drawingml/2006/main" noGrp="1"/>
           </p:cNvSpPr>
@@ -2525,6 +2758,7 @@
           <a:lstStyle xmlns:a="http://schemas.openxmlformats.org/drawingml/2006/main"/>
           <a:p xmlns:a="http://schemas.openxmlformats.org/drawingml/2006/main">
             <a:pPr algn="ctr">
+              <a:buNone/>
               <a:defRPr sz="900" b="0">
                 <a:solidFill>
                   <a:srgbClr val="334155"/>
@@ -2542,6 +2776,7 @@
           </a:p>
           <a:p xmlns:a="http://schemas.openxmlformats.org/drawingml/2006/main">
             <a:pPr algn="ctr">
+              <a:buNone/>
               <a:defRPr sz="900" b="0">
                 <a:solidFill>
                   <a:srgbClr val="334155"/>
@@ -2559,6 +2794,7 @@
           </a:p>
           <a:p xmlns:a="http://schemas.openxmlformats.org/drawingml/2006/main">
             <a:pPr algn="ctr">
+              <a:buNone/>
               <a:defRPr sz="900" b="0">
                 <a:solidFill>
                   <a:srgbClr val="334155"/>
@@ -2578,7 +2814,13 @@
       </p:sp>
       <p:sp>
         <p:nvSpPr>
-          <p:cNvPr id="49" name="pixel-panic-api container"/>
+          <p:cNvPr id="49" name="pixel-panic-api container">
+            <a:extLst xmlns:a="http://schemas.openxmlformats.org/drawingml/2006/main">
+              <a:ext uri="{FF2B5EF4-FFF2-40B4-BE49-F238E27FC236}">
+                <a16:creationId xmlns:a16="http://schemas.microsoft.com/office/drawing/2014/main" id="{05AF2EFF-8B2F-490B-B37B-D93CE1FAA29A}"/>
+              </a:ext>
+            </a:extLst>
+          </p:cNvPr>
           <p:cNvSpPr>
             <a:spLocks xmlns:a="http://schemas.openxmlformats.org/drawingml/2006/main" noGrp="1"/>
           </p:cNvSpPr>
@@ -2607,7 +2849,13 @@
       </p:sp>
       <p:sp>
         <p:nvSpPr>
-          <p:cNvPr id="50" name="API container title"/>
+          <p:cNvPr id="50" name="API container title">
+            <a:extLst xmlns:a="http://schemas.openxmlformats.org/drawingml/2006/main">
+              <a:ext uri="{FF2B5EF4-FFF2-40B4-BE49-F238E27FC236}">
+                <a16:creationId xmlns:a16="http://schemas.microsoft.com/office/drawing/2014/main" id="{31B1EF80-807D-46CF-A7CA-359992E8EBC5}"/>
+              </a:ext>
+            </a:extLst>
+          </p:cNvPr>
           <p:cNvSpPr>
             <a:spLocks xmlns:a="http://schemas.openxmlformats.org/drawingml/2006/main" noGrp="1"/>
           </p:cNvSpPr>
@@ -2632,6 +2880,7 @@
           <a:lstStyle xmlns:a="http://schemas.openxmlformats.org/drawingml/2006/main"/>
           <a:p xmlns:a="http://schemas.openxmlformats.org/drawingml/2006/main">
             <a:pPr algn="ctr">
+              <a:buNone/>
               <a:defRPr sz="1125" b="1">
                 <a:solidFill>
                   <a:srgbClr val="155E75"/>
@@ -2651,7 +2900,13 @@
       </p:sp>
       <p:sp>
         <p:nvSpPr>
-          <p:cNvPr id="51" name="API container detail"/>
+          <p:cNvPr id="51" name="API container detail">
+            <a:extLst xmlns:a="http://schemas.openxmlformats.org/drawingml/2006/main">
+              <a:ext uri="{FF2B5EF4-FFF2-40B4-BE49-F238E27FC236}">
+                <a16:creationId xmlns:a16="http://schemas.microsoft.com/office/drawing/2014/main" id="{FFD7FD03-7675-4387-9B8A-1F24B6DA58CD}"/>
+              </a:ext>
+            </a:extLst>
+          </p:cNvPr>
           <p:cNvSpPr>
             <a:spLocks xmlns:a="http://schemas.openxmlformats.org/drawingml/2006/main" noGrp="1"/>
           </p:cNvSpPr>
@@ -2676,6 +2931,7 @@
           <a:lstStyle xmlns:a="http://schemas.openxmlformats.org/drawingml/2006/main"/>
           <a:p xmlns:a="http://schemas.openxmlformats.org/drawingml/2006/main">
             <a:pPr algn="ctr">
+              <a:buNone/>
               <a:defRPr sz="900" b="0">
                 <a:solidFill>
                   <a:srgbClr val="155E75"/>
@@ -2693,6 +2949,7 @@
           </a:p>
           <a:p xmlns:a="http://schemas.openxmlformats.org/drawingml/2006/main">
             <a:pPr algn="ctr">
+              <a:buNone/>
               <a:defRPr sz="900" b="0">
                 <a:solidFill>
                   <a:srgbClr val="155E75"/>
@@ -2705,11 +2962,12 @@
                   <a:srgbClr val="155E75"/>
                 </a:solidFill>
               </a:rPr>
-              <a:t>/health · /v1/plan</a:t>
+              <a:t>/health · /api/dialogue</a:t>
             </a:r>
           </a:p>
           <a:p xmlns:a="http://schemas.openxmlformats.org/drawingml/2006/main">
             <a:pPr algn="ctr">
+              <a:buNone/>
               <a:defRPr sz="900" b="0">
                 <a:solidFill>
                   <a:srgbClr val="155E75"/>
@@ -2722,14 +2980,20 @@
                   <a:srgbClr val="155E75"/>
                 </a:solidFill>
               </a:rPr>
-              <a:t>Auth · rate limit · cache · request ID logs</a:t>
-            </a:r>
-          </a:p>
-        </p:txBody>
-      </p:sp>
-      <p:sp>
-        <p:nvSpPr>
-          <p:cNvPr id="52" name="Server-only Secrets"/>
+              <a:t>Auth · rate limit · schema · request ID logs</a:t>
+            </a:r>
+          </a:p>
+        </p:txBody>
+      </p:sp>
+      <p:sp>
+        <p:nvSpPr>
+          <p:cNvPr id="52" name="Server-only Secrets">
+            <a:extLst xmlns:a="http://schemas.openxmlformats.org/drawingml/2006/main">
+              <a:ext uri="{FF2B5EF4-FFF2-40B4-BE49-F238E27FC236}">
+                <a16:creationId xmlns:a16="http://schemas.microsoft.com/office/drawing/2014/main" id="{28653B3F-F65A-492B-A10E-B6802070628D}"/>
+              </a:ext>
+            </a:extLst>
+          </p:cNvPr>
           <p:cNvSpPr>
             <a:spLocks xmlns:a="http://schemas.openxmlformats.org/drawingml/2006/main" noGrp="1"/>
           </p:cNvSpPr>
@@ -2758,7 +3022,13 @@
       </p:sp>
       <p:sp>
         <p:nvSpPr>
-          <p:cNvPr id="53" name="Server-only Secrets label"/>
+          <p:cNvPr id="53" name="Server-only Secrets label">
+            <a:extLst xmlns:a="http://schemas.openxmlformats.org/drawingml/2006/main">
+              <a:ext uri="{FF2B5EF4-FFF2-40B4-BE49-F238E27FC236}">
+                <a16:creationId xmlns:a16="http://schemas.microsoft.com/office/drawing/2014/main" id="{7D201302-7F78-4B40-A2C3-629D1EB5F760}"/>
+              </a:ext>
+            </a:extLst>
+          </p:cNvPr>
           <p:cNvSpPr>
             <a:spLocks xmlns:a="http://schemas.openxmlformats.org/drawingml/2006/main" noGrp="1"/>
           </p:cNvSpPr>
@@ -2783,6 +3053,7 @@
           <a:lstStyle xmlns:a="http://schemas.openxmlformats.org/drawingml/2006/main"/>
           <a:p xmlns:a="http://schemas.openxmlformats.org/drawingml/2006/main">
             <a:pPr algn="ctr">
+              <a:buNone/>
               <a:defRPr sz="863" b="1">
                 <a:solidFill>
                   <a:srgbClr val="9A3412"/>
@@ -2800,6 +3071,7 @@
           </a:p>
           <a:p xmlns:a="http://schemas.openxmlformats.org/drawingml/2006/main">
             <a:pPr algn="ctr">
+              <a:buNone/>
               <a:defRPr sz="863" b="1">
                 <a:solidFill>
                   <a:srgbClr val="9A3412"/>
@@ -2819,7 +3091,13 @@
       </p:sp>
       <p:sp>
         <p:nvSpPr>
-          <p:cNvPr id="54" name="OpenAI API boundary"/>
+          <p:cNvPr id="54" name="OpenAI API boundary">
+            <a:extLst xmlns:a="http://schemas.openxmlformats.org/drawingml/2006/main">
+              <a:ext uri="{FF2B5EF4-FFF2-40B4-BE49-F238E27FC236}">
+                <a16:creationId xmlns:a16="http://schemas.microsoft.com/office/drawing/2014/main" id="{2382A9A2-2B41-4BA8-8836-9CC246AEA338}"/>
+              </a:ext>
+            </a:extLst>
+          </p:cNvPr>
           <p:cNvSpPr>
             <a:spLocks xmlns:a="http://schemas.openxmlformats.org/drawingml/2006/main" noGrp="1"/>
           </p:cNvSpPr>
@@ -2848,7 +3126,13 @@
       </p:sp>
       <p:sp>
         <p:nvSpPr>
-          <p:cNvPr id="55" name="OpenAI generic API badge"/>
+          <p:cNvPr id="55" name="OpenAI generic API badge">
+            <a:extLst xmlns:a="http://schemas.openxmlformats.org/drawingml/2006/main">
+              <a:ext uri="{FF2B5EF4-FFF2-40B4-BE49-F238E27FC236}">
+                <a16:creationId xmlns:a16="http://schemas.microsoft.com/office/drawing/2014/main" id="{96783804-839D-4F71-9F97-6FAEBFF6332B}"/>
+              </a:ext>
+            </a:extLst>
+          </p:cNvPr>
           <p:cNvSpPr>
             <a:spLocks xmlns:a="http://schemas.openxmlformats.org/drawingml/2006/main" noGrp="1"/>
           </p:cNvSpPr>
@@ -2877,6 +3161,7 @@
           <a:lstStyle xmlns:a="http://schemas.openxmlformats.org/drawingml/2006/main"/>
           <a:p xmlns:a="http://schemas.openxmlformats.org/drawingml/2006/main">
             <a:pPr algn="ctr">
+              <a:buNone/>
               <a:defRPr sz="1425" b="1">
                 <a:solidFill>
                   <a:srgbClr val="FFFFFF"/>
@@ -2896,7 +3181,13 @@
       </p:sp>
       <p:sp>
         <p:nvSpPr>
-          <p:cNvPr id="56" name="OpenAI Responses API label"/>
+          <p:cNvPr id="56" name="OpenAI Responses API label">
+            <a:extLst xmlns:a="http://schemas.openxmlformats.org/drawingml/2006/main">
+              <a:ext uri="{FF2B5EF4-FFF2-40B4-BE49-F238E27FC236}">
+                <a16:creationId xmlns:a16="http://schemas.microsoft.com/office/drawing/2014/main" id="{83F01FE1-0847-4E84-912A-776C50C5D3ED}"/>
+              </a:ext>
+            </a:extLst>
+          </p:cNvPr>
           <p:cNvSpPr>
             <a:spLocks xmlns:a="http://schemas.openxmlformats.org/drawingml/2006/main" noGrp="1"/>
           </p:cNvSpPr>
@@ -2921,6 +3212,7 @@
           <a:lstStyle xmlns:a="http://schemas.openxmlformats.org/drawingml/2006/main"/>
           <a:p xmlns:a="http://schemas.openxmlformats.org/drawingml/2006/main">
             <a:pPr algn="ctr">
+              <a:buNone/>
               <a:defRPr sz="1350" b="1">
                 <a:solidFill>
                   <a:srgbClr val="065F46"/>
@@ -2938,6 +3230,7 @@
           </a:p>
           <a:p xmlns:a="http://schemas.openxmlformats.org/drawingml/2006/main">
             <a:pPr algn="ctr">
+              <a:buNone/>
               <a:defRPr sz="1350" b="1">
                 <a:solidFill>
                   <a:srgbClr val="065F46"/>
@@ -2957,7 +3250,13 @@
       </p:sp>
       <p:sp>
         <p:nvSpPr>
-          <p:cNvPr id="57" name="IGW connector anchor"/>
+          <p:cNvPr id="57" name="IGW connector anchor">
+            <a:extLst xmlns:a="http://schemas.openxmlformats.org/drawingml/2006/main">
+              <a:ext uri="{FF2B5EF4-FFF2-40B4-BE49-F238E27FC236}">
+                <a16:creationId xmlns:a16="http://schemas.microsoft.com/office/drawing/2014/main" id="{891DCFA9-304C-4E20-9D81-71BD8C83CAF7}"/>
+              </a:ext>
+            </a:extLst>
+          </p:cNvPr>
           <p:cNvSpPr>
             <a:spLocks xmlns:a="http://schemas.openxmlformats.org/drawingml/2006/main" noGrp="1"/>
           </p:cNvSpPr>
@@ -2980,7 +3279,7 @@
       </p:sp>
       <p:cxnSp>
         <p:nvCxnSpPr>
-          <p:cNvPr id="116" name=""/>
+          <p:cNvPr id="234" name=""/>
           <p:cNvCxnSpPr>
             <a:stCxn xmlns:a="http://schemas.openxmlformats.org/drawingml/2006/main" id="29" idx="3"/>
             <a:endCxn xmlns:a="http://schemas.openxmlformats.org/drawingml/2006/main" id="33" idx="1"/>
@@ -3006,7 +3305,7 @@
       </p:cxnSp>
       <p:cxnSp>
         <p:nvCxnSpPr>
-          <p:cNvPr id="117" name=""/>
+          <p:cNvPr id="235" name=""/>
           <p:cNvCxnSpPr>
             <a:stCxn xmlns:a="http://schemas.openxmlformats.org/drawingml/2006/main" id="33" idx="2"/>
             <a:endCxn xmlns:a="http://schemas.openxmlformats.org/drawingml/2006/main" id="36" idx="0"/>
@@ -3032,7 +3331,7 @@
       </p:cxnSp>
       <p:cxnSp>
         <p:nvCxnSpPr>
-          <p:cNvPr id="118" name=""/>
+          <p:cNvPr id="236" name=""/>
           <p:cNvCxnSpPr>
             <a:stCxn xmlns:a="http://schemas.openxmlformats.org/drawingml/2006/main" id="36" idx="2"/>
             <a:endCxn xmlns:a="http://schemas.openxmlformats.org/drawingml/2006/main" id="41" idx="0"/>
@@ -3058,7 +3357,7 @@
       </p:cxnSp>
       <p:cxnSp>
         <p:nvCxnSpPr>
-          <p:cNvPr id="119" name=""/>
+          <p:cNvPr id="237" name=""/>
           <p:cNvCxnSpPr>
             <a:stCxn xmlns:a="http://schemas.openxmlformats.org/drawingml/2006/main" id="36" idx="3"/>
             <a:endCxn xmlns:a="http://schemas.openxmlformats.org/drawingml/2006/main" id="57" idx="1"/>
@@ -3084,7 +3383,7 @@
       </p:cxnSp>
       <p:cxnSp>
         <p:nvCxnSpPr>
-          <p:cNvPr id="120" name=""/>
+          <p:cNvPr id="238" name=""/>
           <p:cNvCxnSpPr>
             <a:stCxn xmlns:a="http://schemas.openxmlformats.org/drawingml/2006/main" id="57" idx="3"/>
             <a:endCxn xmlns:a="http://schemas.openxmlformats.org/drawingml/2006/main" id="44" idx="1"/>
@@ -3110,7 +3409,7 @@
       </p:cxnSp>
       <p:cxnSp>
         <p:nvCxnSpPr>
-          <p:cNvPr id="121" name=""/>
+          <p:cNvPr id="239" name=""/>
           <p:cNvCxnSpPr>
             <a:stCxn xmlns:a="http://schemas.openxmlformats.org/drawingml/2006/main" id="49" idx="3"/>
             <a:endCxn xmlns:a="http://schemas.openxmlformats.org/drawingml/2006/main" id="54" idx="1"/>
@@ -3136,7 +3435,13 @@
       </p:cxnSp>
       <p:sp>
         <p:nvSpPr>
-          <p:cNvPr id="64" name="Browser to Vercel protocol"/>
+          <p:cNvPr id="64" name="Browser to Vercel protocol">
+            <a:extLst xmlns:a="http://schemas.openxmlformats.org/drawingml/2006/main">
+              <a:ext uri="{FF2B5EF4-FFF2-40B4-BE49-F238E27FC236}">
+                <a16:creationId xmlns:a16="http://schemas.microsoft.com/office/drawing/2014/main" id="{9C3A2FD7-E622-4DC7-A209-D53F91F90E06}"/>
+              </a:ext>
+            </a:extLst>
+          </p:cNvPr>
           <p:cNvSpPr>
             <a:spLocks xmlns:a="http://schemas.openxmlformats.org/drawingml/2006/main" noGrp="1"/>
           </p:cNvSpPr>
@@ -3161,6 +3466,7 @@
           <a:lstStyle xmlns:a="http://schemas.openxmlformats.org/drawingml/2006/main"/>
           <a:p xmlns:a="http://schemas.openxmlformats.org/drawingml/2006/main">
             <a:pPr algn="ctr">
+              <a:buNone/>
               <a:defRPr sz="975" b="1">
                 <a:solidFill>
                   <a:srgbClr val="0369A1"/>
@@ -3180,7 +3486,13 @@
       </p:sp>
       <p:sp>
         <p:nvSpPr>
-          <p:cNvPr id="65" name="Vercel to OCI protocol"/>
+          <p:cNvPr id="65" name="Vercel to OCI protocol">
+            <a:extLst xmlns:a="http://schemas.openxmlformats.org/drawingml/2006/main">
+              <a:ext uri="{FF2B5EF4-FFF2-40B4-BE49-F238E27FC236}">
+                <a16:creationId xmlns:a16="http://schemas.microsoft.com/office/drawing/2014/main" id="{A0FBE5A2-07CA-4543-BB25-D528E836330F}"/>
+              </a:ext>
+            </a:extLst>
+          </p:cNvPr>
           <p:cNvSpPr>
             <a:spLocks xmlns:a="http://schemas.openxmlformats.org/drawingml/2006/main" noGrp="1"/>
           </p:cNvSpPr>
@@ -3205,6 +3517,7 @@
           <a:lstStyle xmlns:a="http://schemas.openxmlformats.org/drawingml/2006/main"/>
           <a:p xmlns:a="http://schemas.openxmlformats.org/drawingml/2006/main">
             <a:pPr algn="ctr">
+              <a:buNone/>
               <a:defRPr sz="975" b="1">
                 <a:solidFill>
                   <a:srgbClr val="C2410C"/>
@@ -3222,6 +3535,7 @@
           </a:p>
           <a:p xmlns:a="http://schemas.openxmlformats.org/drawingml/2006/main">
             <a:pPr algn="ctr">
+              <a:buNone/>
               <a:defRPr sz="975" b="1">
                 <a:solidFill>
                   <a:srgbClr val="C2410C"/>
@@ -3241,7 +3555,13 @@
       </p:sp>
       <p:sp>
         <p:nvSpPr>
-          <p:cNvPr id="66" name="OCI to OpenAI protocol"/>
+          <p:cNvPr id="66" name="OCI to OpenAI protocol">
+            <a:extLst xmlns:a="http://schemas.openxmlformats.org/drawingml/2006/main">
+              <a:ext uri="{FF2B5EF4-FFF2-40B4-BE49-F238E27FC236}">
+                <a16:creationId xmlns:a16="http://schemas.microsoft.com/office/drawing/2014/main" id="{2BA0AE29-207C-4DB6-B27F-81CEDF50556E}"/>
+              </a:ext>
+            </a:extLst>
+          </p:cNvPr>
           <p:cNvSpPr>
             <a:spLocks xmlns:a="http://schemas.openxmlformats.org/drawingml/2006/main" noGrp="1"/>
           </p:cNvSpPr>
@@ -3266,6 +3586,7 @@
           <a:lstStyle xmlns:a="http://schemas.openxmlformats.org/drawingml/2006/main"/>
           <a:p xmlns:a="http://schemas.openxmlformats.org/drawingml/2006/main">
             <a:pPr algn="ctr">
+              <a:buNone/>
               <a:defRPr sz="975" b="1">
                 <a:solidFill>
                   <a:srgbClr val="047857"/>
@@ -3285,7 +3606,13 @@
       </p:sp>
       <p:sp>
         <p:nvSpPr>
-          <p:cNvPr id="67" name="Fallback reason label"/>
+          <p:cNvPr id="67" name="Fallback reason label">
+            <a:extLst xmlns:a="http://schemas.openxmlformats.org/drawingml/2006/main">
+              <a:ext uri="{FF2B5EF4-FFF2-40B4-BE49-F238E27FC236}">
+                <a16:creationId xmlns:a16="http://schemas.microsoft.com/office/drawing/2014/main" id="{EDE19F12-8FA9-4724-8C31-427D224D1915}"/>
+              </a:ext>
+            </a:extLst>
+          </p:cNvPr>
           <p:cNvSpPr>
             <a:spLocks xmlns:a="http://schemas.openxmlformats.org/drawingml/2006/main" noGrp="1"/>
           </p:cNvSpPr>
@@ -3310,6 +3637,7 @@
           <a:lstStyle xmlns:a="http://schemas.openxmlformats.org/drawingml/2006/main"/>
           <a:p xmlns:a="http://schemas.openxmlformats.org/drawingml/2006/main">
             <a:pPr algn="r">
+              <a:buNone/>
               <a:defRPr sz="863" b="0">
                 <a:solidFill>
                   <a:srgbClr val="64748B"/>
@@ -3329,7 +3657,13 @@
       </p:sp>
       <p:sp>
         <p:nvSpPr>
-          <p:cNvPr id="68" name="Deployment path note"/>
+          <p:cNvPr id="68" name="Deployment path note">
+            <a:extLst xmlns:a="http://schemas.openxmlformats.org/drawingml/2006/main">
+              <a:ext uri="{FF2B5EF4-FFF2-40B4-BE49-F238E27FC236}">
+                <a16:creationId xmlns:a16="http://schemas.microsoft.com/office/drawing/2014/main" id="{EEFDD100-2421-4964-8BF6-720CCC14C0B0}"/>
+              </a:ext>
+            </a:extLst>
+          </p:cNvPr>
           <p:cNvSpPr>
             <a:spLocks xmlns:a="http://schemas.openxmlformats.org/drawingml/2006/main" noGrp="1"/>
           </p:cNvSpPr>
@@ -3354,6 +3688,7 @@
           <a:lstStyle xmlns:a="http://schemas.openxmlformats.org/drawingml/2006/main"/>
           <a:p xmlns:a="http://schemas.openxmlformats.org/drawingml/2006/main">
             <a:pPr algn="ctr">
+              <a:buNone/>
               <a:defRPr sz="938" b="0">
                 <a:solidFill>
                   <a:srgbClr val="64748B"/>
@@ -3395,7 +3730,13 @@
       </p:grpSpPr>
       <p:sp>
         <p:nvSpPr>
-          <p:cNvPr id="2" name="Background"/>
+          <p:cNvPr id="2" name="Background">
+            <a:extLst xmlns:a="http://schemas.openxmlformats.org/drawingml/2006/main">
+              <a:ext uri="{FF2B5EF4-FFF2-40B4-BE49-F238E27FC236}">
+                <a16:creationId xmlns:a16="http://schemas.microsoft.com/office/drawing/2014/main" id="{AF54AAA5-BCDF-4C27-9A3C-E4189800A8FC}"/>
+              </a:ext>
+            </a:extLst>
+          </p:cNvPr>
           <p:cNvSpPr>
             <a:spLocks xmlns:a="http://schemas.openxmlformats.org/drawingml/2006/main" noGrp="1"/>
           </p:cNvSpPr>
@@ -3419,7 +3760,13 @@
       </p:sp>
       <p:sp>
         <p:nvSpPr>
-          <p:cNvPr id="3" name="Notes title"/>
+          <p:cNvPr id="3" name="Notes title">
+            <a:extLst xmlns:a="http://schemas.openxmlformats.org/drawingml/2006/main">
+              <a:ext uri="{FF2B5EF4-FFF2-40B4-BE49-F238E27FC236}">
+                <a16:creationId xmlns:a16="http://schemas.microsoft.com/office/drawing/2014/main" id="{3BB95D12-4BF3-430F-88F6-B31B104B842E}"/>
+              </a:ext>
+            </a:extLst>
+          </p:cNvPr>
           <p:cNvSpPr>
             <a:spLocks xmlns:a="http://schemas.openxmlformats.org/drawingml/2006/main" noGrp="1"/>
           </p:cNvSpPr>
@@ -3464,7 +3811,13 @@
       </p:sp>
       <p:sp>
         <p:nvSpPr>
-          <p:cNvPr id="4" name="Assumptions box"/>
+          <p:cNvPr id="4" name="Assumptions box">
+            <a:extLst xmlns:a="http://schemas.openxmlformats.org/drawingml/2006/main">
+              <a:ext uri="{FF2B5EF4-FFF2-40B4-BE49-F238E27FC236}">
+                <a16:creationId xmlns:a16="http://schemas.microsoft.com/office/drawing/2014/main" id="{FD85D659-DA5E-47EF-B39B-442760EE90A7}"/>
+              </a:ext>
+            </a:extLst>
+          </p:cNvPr>
           <p:cNvSpPr>
             <a:spLocks xmlns:a="http://schemas.openxmlformats.org/drawingml/2006/main" noGrp="1"/>
           </p:cNvSpPr>
@@ -3490,7 +3843,13 @@
       </p:sp>
       <p:sp>
         <p:nvSpPr>
-          <p:cNvPr id="5" name="Assumptions"/>
+          <p:cNvPr id="5" name="Assumptions">
+            <a:extLst xmlns:a="http://schemas.openxmlformats.org/drawingml/2006/main">
+              <a:ext uri="{FF2B5EF4-FFF2-40B4-BE49-F238E27FC236}">
+                <a16:creationId xmlns:a16="http://schemas.microsoft.com/office/drawing/2014/main" id="{0EDDA6FB-792D-4FE3-AFBA-EE179B32D286}"/>
+              </a:ext>
+            </a:extLst>
+          </p:cNvPr>
           <p:cNvSpPr>
             <a:spLocks xmlns:a="http://schemas.openxmlformats.org/drawingml/2006/main" noGrp="1"/>
           </p:cNvSpPr>
@@ -3511,7 +3870,7 @@
         </p:spPr>
         <p:txBody>
           <a:bodyPr xmlns:a="http://schemas.openxmlformats.org/drawingml/2006/main" wrap="square" lIns="45720" tIns="45720" rIns="45720" bIns="45720" anchor="t">
-            <a:normAutofit/>
+            <a:normAutofit fontScale="100000"/>
           </a:bodyPr>
           <a:lstStyle xmlns:a="http://schemas.openxmlformats.org/drawingml/2006/main"/>
           <a:p xmlns:a="http://schemas.openxmlformats.org/drawingml/2006/main">
@@ -3578,7 +3937,7 @@
                 <a:ea typeface="Aptos"/>
                 <a:cs typeface="Aptos"/>
               </a:rPr>
-              <a:t>- 브라우저는 Vercel의 same-origin /api/plan만 호출하며 OCI VM이나 OpenAI를 직접 호출하지 않습니다.</a:t>
+              <a:t>- 브라우저는 대사 이벤트에서 Vercel same-origin /api/dialogue만 호출하며 OCI VM이나 OpenAI를 직접 호출하지 않습니다.</a:t>
             </a:r>
             <a:endParaRPr sz="1000"/>
           </a:p>
@@ -3586,7 +3945,13 @@
       </p:sp>
       <p:sp>
         <p:nvSpPr>
-          <p:cNvPr id="6" name="Security box"/>
+          <p:cNvPr id="6" name="Security box">
+            <a:extLst xmlns:a="http://schemas.openxmlformats.org/drawingml/2006/main">
+              <a:ext uri="{FF2B5EF4-FFF2-40B4-BE49-F238E27FC236}">
+                <a16:creationId xmlns:a16="http://schemas.microsoft.com/office/drawing/2014/main" id="{51799296-9AAC-4460-8AA0-F6208FA68937}"/>
+              </a:ext>
+            </a:extLst>
+          </p:cNvPr>
           <p:cNvSpPr>
             <a:spLocks xmlns:a="http://schemas.openxmlformats.org/drawingml/2006/main" noGrp="1"/>
           </p:cNvSpPr>
@@ -3612,7 +3977,13 @@
       </p:sp>
       <p:sp>
         <p:nvSpPr>
-          <p:cNvPr id="7" name="Security notes"/>
+          <p:cNvPr id="7" name="Security notes">
+            <a:extLst xmlns:a="http://schemas.openxmlformats.org/drawingml/2006/main">
+              <a:ext uri="{FF2B5EF4-FFF2-40B4-BE49-F238E27FC236}">
+                <a16:creationId xmlns:a16="http://schemas.microsoft.com/office/drawing/2014/main" id="{0E2F38D5-C7AC-41E3-88C4-4A74B699FA6A}"/>
+              </a:ext>
+            </a:extLst>
+          </p:cNvPr>
           <p:cNvSpPr>
             <a:spLocks xmlns:a="http://schemas.openxmlformats.org/drawingml/2006/main" noGrp="1"/>
           </p:cNvSpPr>
@@ -3676,7 +4047,7 @@
                 <a:ea typeface="Aptos"/>
                 <a:cs typeface="Aptos"/>
               </a:rPr>
-              <a:t>- 브라우저는 same-origin /api/plan만 호출하며 OCI 주소와 토큰을 알지 못합니다.</a:t>
+              <a:t>- 게임 판정은 브라우저의 결정론적 엔진이 수행하고 AI는 4개 대사 이벤트에만 사용합니다.</a:t>
             </a:r>
             <a:endParaRPr sz="1000"/>
           </a:p>
@@ -3698,7 +4069,7 @@
                 <a:ea typeface="Aptos"/>
                 <a:cs typeface="Aptos"/>
               </a:rPr>
-              <a:t>- Vercel 서버 Route는 HTTP 8080 + Bearer로 OCI /v1/plan을 호출합니다.</a:t>
+              <a:t>- Vercel 서버 Route는 HTTP 8080 + Bearer로 OCI /api/dialogue를 호출합니다.</a:t>
             </a:r>
             <a:endParaRPr sz="1000"/>
           </a:p>
@@ -3742,7 +4113,7 @@
                 <a:ea typeface="Aptos"/>
                 <a:cs typeface="Aptos"/>
               </a:rPr>
-              <a:t>- OCI timeout/장애/429/5xx/invalid schema에서는 동일 schema LOCAL fallback을 반환합니다.</a:t>
+              <a:t>- OCI timeout/장애/429/5xx/invalid schema에서는 정적 LOCAL 대사 fallback을 반환합니다.</a:t>
             </a:r>
             <a:endParaRPr sz="1000"/>
           </a:p>
@@ -3764,7 +4135,7 @@
                 <a:ea typeface="Aptos"/>
                 <a:cs typeface="Aptos"/>
               </a:rPr>
-              <a:t>- Fastify는 인증, rate/burst 제한, 성공 cache, request ID 상관관계 로그를 적용합니다.</a:t>
+              <a:t>- Fastify는 인증, schema 검증, rate/burst 제한, request ID 상관관계 로그를 적용합니다.</a:t>
             </a:r>
             <a:endParaRPr sz="1000"/>
           </a:p>
@@ -3816,7 +4187,13 @@
       </p:sp>
       <p:sp>
         <p:nvSpPr>
-          <p:cNvPr id="8" name="Rendering box"/>
+          <p:cNvPr id="8" name="Rendering box">
+            <a:extLst xmlns:a="http://schemas.openxmlformats.org/drawingml/2006/main">
+              <a:ext uri="{FF2B5EF4-FFF2-40B4-BE49-F238E27FC236}">
+                <a16:creationId xmlns:a16="http://schemas.microsoft.com/office/drawing/2014/main" id="{5913C447-ADC7-4889-A192-C3955A7AC0C7}"/>
+              </a:ext>
+            </a:extLst>
+          </p:cNvPr>
           <p:cNvSpPr>
             <a:spLocks xmlns:a="http://schemas.openxmlformats.org/drawingml/2006/main" noGrp="1"/>
           </p:cNvSpPr>
@@ -3842,7 +4219,13 @@
       </p:sp>
       <p:sp>
         <p:nvSpPr>
-          <p:cNvPr id="9" name="Rendering notes"/>
+          <p:cNvPr id="9" name="Rendering notes">
+            <a:extLst xmlns:a="http://schemas.openxmlformats.org/drawingml/2006/main">
+              <a:ext uri="{FF2B5EF4-FFF2-40B4-BE49-F238E27FC236}">
+                <a16:creationId xmlns:a16="http://schemas.microsoft.com/office/drawing/2014/main" id="{B35E3302-81D3-47B9-96D2-E81AD7A37A51}"/>
+              </a:ext>
+            </a:extLst>
+          </p:cNvPr>
           <p:cNvSpPr>
             <a:spLocks xmlns:a="http://schemas.openxmlformats.org/drawingml/2006/main" noGrp="1"/>
           </p:cNvSpPr>
@@ -4002,7 +4385,13 @@
       </p:grpSpPr>
       <p:sp>
         <p:nvSpPr>
-          <p:cNvPr id="2" name="Background"/>
+          <p:cNvPr id="2" name="Background">
+            <a:extLst xmlns:a="http://schemas.openxmlformats.org/drawingml/2006/main">
+              <a:ext uri="{FF2B5EF4-FFF2-40B4-BE49-F238E27FC236}">
+                <a16:creationId xmlns:a16="http://schemas.microsoft.com/office/drawing/2014/main" id="{848E382D-B040-444C-914A-A7EFF44F9374}"/>
+              </a:ext>
+            </a:extLst>
+          </p:cNvPr>
           <p:cNvSpPr>
             <a:spLocks xmlns:a="http://schemas.openxmlformats.org/drawingml/2006/main" noGrp="1"/>
           </p:cNvSpPr>
@@ -4026,7 +4415,13 @@
       </p:sp>
       <p:sp>
         <p:nvSpPr>
-          <p:cNvPr id="3" name="Advice title"/>
+          <p:cNvPr id="3" name="Advice title">
+            <a:extLst xmlns:a="http://schemas.openxmlformats.org/drawingml/2006/main">
+              <a:ext uri="{FF2B5EF4-FFF2-40B4-BE49-F238E27FC236}">
+                <a16:creationId xmlns:a16="http://schemas.microsoft.com/office/drawing/2014/main" id="{6331B414-7F70-4C84-9356-B46F2D335127}"/>
+              </a:ext>
+            </a:extLst>
+          </p:cNvPr>
           <p:cNvSpPr>
             <a:spLocks xmlns:a="http://schemas.openxmlformats.org/drawingml/2006/main" noGrp="1"/>
           </p:cNvSpPr>
@@ -4071,7 +4466,13 @@
       </p:sp>
       <p:sp>
         <p:nvSpPr>
-          <p:cNvPr id="4" name="Advice subtitle"/>
+          <p:cNvPr id="4" name="Advice subtitle">
+            <a:extLst xmlns:a="http://schemas.openxmlformats.org/drawingml/2006/main">
+              <a:ext uri="{FF2B5EF4-FFF2-40B4-BE49-F238E27FC236}">
+                <a16:creationId xmlns:a16="http://schemas.microsoft.com/office/drawing/2014/main" id="{7B393C2C-CF3B-4963-946E-1789BCDC4FDF}"/>
+              </a:ext>
+            </a:extLst>
+          </p:cNvPr>
           <p:cNvSpPr>
             <a:spLocks xmlns:a="http://schemas.openxmlformats.org/drawingml/2006/main" noGrp="1"/>
           </p:cNvSpPr>
@@ -4121,7 +4522,13 @@
       </p:sp>
       <p:sp>
         <p:nvSpPr>
-          <p:cNvPr id="5" name="Advice resilience box"/>
+          <p:cNvPr id="5" name="Advice resilience box">
+            <a:extLst xmlns:a="http://schemas.openxmlformats.org/drawingml/2006/main">
+              <a:ext uri="{FF2B5EF4-FFF2-40B4-BE49-F238E27FC236}">
+                <a16:creationId xmlns:a16="http://schemas.microsoft.com/office/drawing/2014/main" id="{2B5CBF2C-B80D-4331-846E-DEFF3BDBC3AD}"/>
+              </a:ext>
+            </a:extLst>
+          </p:cNvPr>
           <p:cNvSpPr>
             <a:spLocks xmlns:a="http://schemas.openxmlformats.org/drawingml/2006/main" noGrp="1"/>
           </p:cNvSpPr>
@@ -4147,7 +4554,13 @@
       </p:sp>
       <p:sp>
         <p:nvSpPr>
-          <p:cNvPr id="6" name="Advice resilience title"/>
+          <p:cNvPr id="6" name="Advice resilience title">
+            <a:extLst xmlns:a="http://schemas.openxmlformats.org/drawingml/2006/main">
+              <a:ext uri="{FF2B5EF4-FFF2-40B4-BE49-F238E27FC236}">
+                <a16:creationId xmlns:a16="http://schemas.microsoft.com/office/drawing/2014/main" id="{D11A7143-8D54-42FE-8343-AEEAD1511F6E}"/>
+              </a:ext>
+            </a:extLst>
+          </p:cNvPr>
           <p:cNvSpPr>
             <a:spLocks xmlns:a="http://schemas.openxmlformats.org/drawingml/2006/main" noGrp="1"/>
           </p:cNvSpPr>
@@ -4192,7 +4605,13 @@
       </p:sp>
       <p:sp>
         <p:nvSpPr>
-          <p:cNvPr id="7" name="Advice resilience items"/>
+          <p:cNvPr id="7" name="Advice resilience items">
+            <a:extLst xmlns:a="http://schemas.openxmlformats.org/drawingml/2006/main">
+              <a:ext uri="{FF2B5EF4-FFF2-40B4-BE49-F238E27FC236}">
+                <a16:creationId xmlns:a16="http://schemas.microsoft.com/office/drawing/2014/main" id="{AD1E5FE6-5AAD-427E-8B36-16D59DBC9E40}"/>
+              </a:ext>
+            </a:extLst>
+          </p:cNvPr>
           <p:cNvSpPr>
             <a:spLocks xmlns:a="http://schemas.openxmlformats.org/drawingml/2006/main" noGrp="1"/>
           </p:cNvSpPr>
@@ -4286,7 +4705,13 @@
       </p:sp>
       <p:sp>
         <p:nvSpPr>
-          <p:cNvPr id="8" name="Advice security box"/>
+          <p:cNvPr id="8" name="Advice security box">
+            <a:extLst xmlns:a="http://schemas.openxmlformats.org/drawingml/2006/main">
+              <a:ext uri="{FF2B5EF4-FFF2-40B4-BE49-F238E27FC236}">
+                <a16:creationId xmlns:a16="http://schemas.microsoft.com/office/drawing/2014/main" id="{DB650ABE-703F-483D-A0E9-3726E381ADD3}"/>
+              </a:ext>
+            </a:extLst>
+          </p:cNvPr>
           <p:cNvSpPr>
             <a:spLocks xmlns:a="http://schemas.openxmlformats.org/drawingml/2006/main" noGrp="1"/>
           </p:cNvSpPr>
@@ -4312,7 +4737,13 @@
       </p:sp>
       <p:sp>
         <p:nvSpPr>
-          <p:cNvPr id="9" name="Advice security title"/>
+          <p:cNvPr id="9" name="Advice security title">
+            <a:extLst xmlns:a="http://schemas.openxmlformats.org/drawingml/2006/main">
+              <a:ext uri="{FF2B5EF4-FFF2-40B4-BE49-F238E27FC236}">
+                <a16:creationId xmlns:a16="http://schemas.microsoft.com/office/drawing/2014/main" id="{60C07F53-7644-47B3-8136-DEF7D6E1D645}"/>
+              </a:ext>
+            </a:extLst>
+          </p:cNvPr>
           <p:cNvSpPr>
             <a:spLocks xmlns:a="http://schemas.openxmlformats.org/drawingml/2006/main" noGrp="1"/>
           </p:cNvSpPr>
@@ -4357,7 +4788,13 @@
       </p:sp>
       <p:sp>
         <p:nvSpPr>
-          <p:cNvPr id="10" name="Advice security items"/>
+          <p:cNvPr id="10" name="Advice security items">
+            <a:extLst xmlns:a="http://schemas.openxmlformats.org/drawingml/2006/main">
+              <a:ext uri="{FF2B5EF4-FFF2-40B4-BE49-F238E27FC236}">
+                <a16:creationId xmlns:a16="http://schemas.microsoft.com/office/drawing/2014/main" id="{1A2280F3-394D-4148-883D-7056C258BC63}"/>
+              </a:ext>
+            </a:extLst>
+          </p:cNvPr>
           <p:cNvSpPr>
             <a:spLocks xmlns:a="http://schemas.openxmlformats.org/drawingml/2006/main" noGrp="1"/>
           </p:cNvSpPr>
@@ -4451,7 +4888,13 @@
       </p:sp>
       <p:sp>
         <p:nvSpPr>
-          <p:cNvPr id="11" name="Advice operations box"/>
+          <p:cNvPr id="11" name="Advice operations box">
+            <a:extLst xmlns:a="http://schemas.openxmlformats.org/drawingml/2006/main">
+              <a:ext uri="{FF2B5EF4-FFF2-40B4-BE49-F238E27FC236}">
+                <a16:creationId xmlns:a16="http://schemas.microsoft.com/office/drawing/2014/main" id="{60E13D89-82BE-461A-818D-DC3F2E137D4C}"/>
+              </a:ext>
+            </a:extLst>
+          </p:cNvPr>
           <p:cNvSpPr>
             <a:spLocks xmlns:a="http://schemas.openxmlformats.org/drawingml/2006/main" noGrp="1"/>
           </p:cNvSpPr>
@@ -4477,7 +4920,13 @@
       </p:sp>
       <p:sp>
         <p:nvSpPr>
-          <p:cNvPr id="12" name="Advice operations title"/>
+          <p:cNvPr id="12" name="Advice operations title">
+            <a:extLst xmlns:a="http://schemas.openxmlformats.org/drawingml/2006/main">
+              <a:ext uri="{FF2B5EF4-FFF2-40B4-BE49-F238E27FC236}">
+                <a16:creationId xmlns:a16="http://schemas.microsoft.com/office/drawing/2014/main" id="{E0184533-A659-402E-B0EB-1472242B570D}"/>
+              </a:ext>
+            </a:extLst>
+          </p:cNvPr>
           <p:cNvSpPr>
             <a:spLocks xmlns:a="http://schemas.openxmlformats.org/drawingml/2006/main" noGrp="1"/>
           </p:cNvSpPr>
@@ -4522,7 +4971,13 @@
       </p:sp>
       <p:sp>
         <p:nvSpPr>
-          <p:cNvPr id="13" name="Advice operations items"/>
+          <p:cNvPr id="13" name="Advice operations items">
+            <a:extLst xmlns:a="http://schemas.openxmlformats.org/drawingml/2006/main">
+              <a:ext uri="{FF2B5EF4-FFF2-40B4-BE49-F238E27FC236}">
+                <a16:creationId xmlns:a16="http://schemas.microsoft.com/office/drawing/2014/main" id="{4AA23CA4-069F-4B88-8D2B-DC271DBE3088}"/>
+              </a:ext>
+            </a:extLst>
+          </p:cNvPr>
           <p:cNvSpPr>
             <a:spLocks xmlns:a="http://schemas.openxmlformats.org/drawingml/2006/main" noGrp="1"/>
           </p:cNvSpPr>
@@ -4616,7 +5071,13 @@
       </p:sp>
       <p:sp>
         <p:nvSpPr>
-          <p:cNvPr id="14" name="Advice cost box"/>
+          <p:cNvPr id="14" name="Advice cost box">
+            <a:extLst xmlns:a="http://schemas.openxmlformats.org/drawingml/2006/main">
+              <a:ext uri="{FF2B5EF4-FFF2-40B4-BE49-F238E27FC236}">
+                <a16:creationId xmlns:a16="http://schemas.microsoft.com/office/drawing/2014/main" id="{8D2E54B1-FB31-4943-B0DE-1EBFB95E927B}"/>
+              </a:ext>
+            </a:extLst>
+          </p:cNvPr>
           <p:cNvSpPr>
             <a:spLocks xmlns:a="http://schemas.openxmlformats.org/drawingml/2006/main" noGrp="1"/>
           </p:cNvSpPr>
@@ -4642,7 +5103,13 @@
       </p:sp>
       <p:sp>
         <p:nvSpPr>
-          <p:cNvPr id="15" name="Advice cost title"/>
+          <p:cNvPr id="15" name="Advice cost title">
+            <a:extLst xmlns:a="http://schemas.openxmlformats.org/drawingml/2006/main">
+              <a:ext uri="{FF2B5EF4-FFF2-40B4-BE49-F238E27FC236}">
+                <a16:creationId xmlns:a16="http://schemas.microsoft.com/office/drawing/2014/main" id="{E0825020-51AE-4983-B4EE-4CF14E583880}"/>
+              </a:ext>
+            </a:extLst>
+          </p:cNvPr>
           <p:cNvSpPr>
             <a:spLocks xmlns:a="http://schemas.openxmlformats.org/drawingml/2006/main" noGrp="1"/>
           </p:cNvSpPr>
@@ -4687,7 +5154,13 @@
       </p:sp>
       <p:sp>
         <p:nvSpPr>
-          <p:cNvPr id="16" name="Advice cost items"/>
+          <p:cNvPr id="16" name="Advice cost items">
+            <a:extLst xmlns:a="http://schemas.openxmlformats.org/drawingml/2006/main">
+              <a:ext uri="{FF2B5EF4-FFF2-40B4-BE49-F238E27FC236}">
+                <a16:creationId xmlns:a16="http://schemas.microsoft.com/office/drawing/2014/main" id="{A6D726E3-6814-48C4-A610-D6ED128105A5}"/>
+              </a:ext>
+            </a:extLst>
+          </p:cNvPr>
           <p:cNvSpPr>
             <a:spLocks xmlns:a="http://schemas.openxmlformats.org/drawingml/2006/main" noGrp="1"/>
           </p:cNvSpPr>
@@ -4749,7 +5222,13 @@
       </p:sp>
       <p:sp>
         <p:nvSpPr>
-          <p:cNvPr id="17" name="Advice open box"/>
+          <p:cNvPr id="17" name="Advice open box">
+            <a:extLst xmlns:a="http://schemas.openxmlformats.org/drawingml/2006/main">
+              <a:ext uri="{FF2B5EF4-FFF2-40B4-BE49-F238E27FC236}">
+                <a16:creationId xmlns:a16="http://schemas.microsoft.com/office/drawing/2014/main" id="{B2EFB70F-923B-4CB5-98DE-CC98ACFC50CB}"/>
+              </a:ext>
+            </a:extLst>
+          </p:cNvPr>
           <p:cNvSpPr>
             <a:spLocks xmlns:a="http://schemas.openxmlformats.org/drawingml/2006/main" noGrp="1"/>
           </p:cNvSpPr>
@@ -4775,7 +5254,13 @@
       </p:sp>
       <p:sp>
         <p:nvSpPr>
-          <p:cNvPr id="18" name="Advice open title"/>
+          <p:cNvPr id="18" name="Advice open title">
+            <a:extLst xmlns:a="http://schemas.openxmlformats.org/drawingml/2006/main">
+              <a:ext uri="{FF2B5EF4-FFF2-40B4-BE49-F238E27FC236}">
+                <a16:creationId xmlns:a16="http://schemas.microsoft.com/office/drawing/2014/main" id="{5D4B1037-52E6-46C2-BEEB-4C2A2567F2BC}"/>
+              </a:ext>
+            </a:extLst>
+          </p:cNvPr>
           <p:cNvSpPr>
             <a:spLocks xmlns:a="http://schemas.openxmlformats.org/drawingml/2006/main" noGrp="1"/>
           </p:cNvSpPr>
@@ -4820,7 +5305,13 @@
       </p:sp>
       <p:sp>
         <p:nvSpPr>
-          <p:cNvPr id="19" name="Advice open items"/>
+          <p:cNvPr id="19" name="Advice open items">
+            <a:extLst xmlns:a="http://schemas.openxmlformats.org/drawingml/2006/main">
+              <a:ext uri="{FF2B5EF4-FFF2-40B4-BE49-F238E27FC236}">
+                <a16:creationId xmlns:a16="http://schemas.microsoft.com/office/drawing/2014/main" id="{ABA095CE-68A0-425F-A727-200049D5B55F}"/>
+              </a:ext>
+            </a:extLst>
+          </p:cNvPr>
           <p:cNvSpPr>
             <a:spLocks xmlns:a="http://schemas.openxmlformats.org/drawingml/2006/main" noGrp="1"/>
           </p:cNvSpPr>
@@ -4936,7 +5427,13 @@
       </p:sp>
       <p:sp>
         <p:nvSpPr>
-          <p:cNvPr id="20" name="Advice footer"/>
+          <p:cNvPr id="20" name="Advice footer">
+            <a:extLst xmlns:a="http://schemas.openxmlformats.org/drawingml/2006/main">
+              <a:ext uri="{FF2B5EF4-FFF2-40B4-BE49-F238E27FC236}">
+                <a16:creationId xmlns:a16="http://schemas.microsoft.com/office/drawing/2014/main" id="{F61BB216-E3D7-4993-B7D1-8F4075CEF763}"/>
+              </a:ext>
+            </a:extLst>
+          </p:cNvPr>
           <p:cNvSpPr>
             <a:spLocks xmlns:a="http://schemas.openxmlformats.org/drawingml/2006/main" noGrp="1"/>
           </p:cNvSpPr>

</xml_diff>